<commit_message>
feat: improve onboarding presentation deck
</commit_message>
<xml_diff>
--- a/presentation/onboard-asof.pptx
+++ b/presentation/onboard-asof.pptx
@@ -19,6 +19,8 @@
     <p:sldId id="267" r:id="rId18"/>
     <p:sldId id="268" r:id="rId19"/>
     <p:sldId id="269" r:id="rId20"/>
+    <p:sldId id="270" r:id="rId21"/>
+    <p:sldId id="271" r:id="rId22"/>
   </p:sldIdLst>
   <p:sldSz cx="12191695" cy="6858000" type="screen4x3"/>
   <p:notesSz cx="6858000" cy="9144000"/>
@@ -3188,42 +3190,77 @@
         <p:spPr>
           <a:xfrm>
             <a:off x="731520" y="2743200"/>
-            <a:ext cx="4572000" cy="457200"/>
-          </a:xfrm>
-          <a:prstGeom prst="rect">
-            <a:avLst/>
-          </a:prstGeom>
-          <a:noFill/>
-        </p:spPr>
-        <p:txBody>
-          <a:bodyPr wrap="square" lIns="0" rIns="0" tIns="0" bIns="0">
-            <a:normAutofit/>
-          </a:bodyPr>
-          <a:lstStyle/>
-          <a:p>
-            <a:pPr algn="l"/>
-            <a:r>
-              <a:rPr sz="1600" b="0">
+            <a:ext cx="4572000" cy="502920"/>
+          </a:xfrm>
+          <a:prstGeom prst="rect">
+            <a:avLst/>
+          </a:prstGeom>
+          <a:noFill/>
+        </p:spPr>
+        <p:txBody>
+          <a:bodyPr wrap="square" lIns="0" rIns="0" tIns="0" bIns="0">
+            <a:normAutofit/>
+          </a:bodyPr>
+          <a:lstStyle/>
+          <a:p>
+            <a:pPr algn="l"/>
+            <a:r>
+              <a:rPr sz="1700" b="1">
+                <a:solidFill>
+                  <a:srgbClr val="FFFFFF"/>
+                </a:solidFill>
+                <a:latin typeface="Aptos"/>
+              </a:rPr>
+              <a:t>Origem, missão, convênios, cadastro e contribuição associativa</a:t>
+            </a:r>
+          </a:p>
+        </p:txBody>
+      </p:sp>
+      <p:sp>
+        <p:nvSpPr>
+          <p:cNvPr id="5" name="TextBox 4"/>
+          <p:cNvSpPr txBox="1"/>
+          <p:nvPr/>
+        </p:nvSpPr>
+        <p:spPr>
+          <a:xfrm>
+            <a:off x="749808" y="3858768"/>
+            <a:ext cx="5120640" cy="320040"/>
+          </a:xfrm>
+          <a:prstGeom prst="rect">
+            <a:avLst/>
+          </a:prstGeom>
+          <a:noFill/>
+        </p:spPr>
+        <p:txBody>
+          <a:bodyPr wrap="square" lIns="0" rIns="0" tIns="0" bIns="0">
+            <a:normAutofit/>
+          </a:bodyPr>
+          <a:lstStyle/>
+          <a:p>
+            <a:pPr algn="l"/>
+            <a:r>
+              <a:rPr sz="1500" b="1">
                 <a:solidFill>
                   <a:srgbClr val="CADCFC"/>
                 </a:solidFill>
                 <a:latin typeface="Aptos"/>
               </a:rPr>
-              <a:t>Origem, missão, convênios, cadastro e contribuição associativa</a:t>
-            </a:r>
-          </a:p>
-        </p:txBody>
-      </p:sp>
-      <p:sp>
-        <p:nvSpPr>
-          <p:cNvPr id="5" name="Rounded Rectangle 4"/>
+              <a:t>1990  •  26 participantes  •  votação 24 x 2</a:t>
+            </a:r>
+          </a:p>
+        </p:txBody>
+      </p:sp>
+      <p:sp>
+        <p:nvSpPr>
+          <p:cNvPr id="6" name="Rounded Rectangle 5"/>
           <p:cNvSpPr/>
           <p:nvPr/>
         </p:nvSpPr>
         <p:spPr>
           <a:xfrm>
-            <a:off x="7680960" y="731520"/>
-            <a:ext cx="3657600" cy="5120640"/>
+            <a:off x="8183879" y="960120"/>
+            <a:ext cx="2880360" cy="4370832"/>
           </a:xfrm>
           <a:prstGeom prst="roundRect">
             <a:avLst/>
@@ -3261,29 +3298,29 @@
       </p:sp>
       <p:sp>
         <p:nvSpPr>
-          <p:cNvPr id="6" name="TextBox 5"/>
-          <p:cNvSpPr txBox="1"/>
-          <p:nvPr/>
-        </p:nvSpPr>
-        <p:spPr>
-          <a:xfrm>
-            <a:off x="8138160" y="1280160"/>
-            <a:ext cx="1828800" cy="640080"/>
-          </a:xfrm>
-          <a:prstGeom prst="rect">
-            <a:avLst/>
-          </a:prstGeom>
-          <a:noFill/>
-        </p:spPr>
-        <p:txBody>
-          <a:bodyPr wrap="square" lIns="0" rIns="0" tIns="0" bIns="0">
-            <a:normAutofit/>
-          </a:bodyPr>
-          <a:lstStyle/>
-          <a:p>
-            <a:pPr algn="l"/>
-            <a:r>
-              <a:rPr sz="3400" b="1">
+          <p:cNvPr id="7" name="TextBox 6"/>
+          <p:cNvSpPr txBox="1"/>
+          <p:nvPr/>
+        </p:nvSpPr>
+        <p:spPr>
+          <a:xfrm>
+            <a:off x="8485632" y="1325880"/>
+            <a:ext cx="1097280" cy="457200"/>
+          </a:xfrm>
+          <a:prstGeom prst="rect">
+            <a:avLst/>
+          </a:prstGeom>
+          <a:noFill/>
+        </p:spPr>
+        <p:txBody>
+          <a:bodyPr wrap="square" lIns="0" rIns="0" tIns="0" bIns="0">
+            <a:normAutofit/>
+          </a:bodyPr>
+          <a:lstStyle/>
+          <a:p>
+            <a:pPr algn="l"/>
+            <a:r>
+              <a:rPr sz="2800" b="1">
                 <a:solidFill>
                   <a:srgbClr val="FFFFFF"/>
                 </a:solidFill>
@@ -3296,41 +3333,41 @@
       </p:sp>
       <p:sp>
         <p:nvSpPr>
-          <p:cNvPr id="7" name="TextBox 6"/>
-          <p:cNvSpPr txBox="1"/>
-          <p:nvPr/>
-        </p:nvSpPr>
-        <p:spPr>
-          <a:xfrm>
-            <a:off x="8138160" y="2011680"/>
-            <a:ext cx="2194560" cy="731520"/>
-          </a:xfrm>
-          <a:prstGeom prst="rect">
-            <a:avLst/>
-          </a:prstGeom>
-          <a:noFill/>
-        </p:spPr>
-        <p:txBody>
-          <a:bodyPr wrap="square" lIns="0" rIns="0" tIns="0" bIns="0">
-            <a:normAutofit/>
-          </a:bodyPr>
-          <a:lstStyle/>
-          <a:p>
-            <a:pPr algn="l"/>
-            <a:r>
-              <a:rPr sz="1800" b="1">
+          <p:cNvPr id="8" name="TextBox 7"/>
+          <p:cNvSpPr txBox="1"/>
+          <p:nvPr/>
+        </p:nvSpPr>
+        <p:spPr>
+          <a:xfrm>
+            <a:off x="8485632" y="1901952"/>
+            <a:ext cx="1993392" cy="566928"/>
+          </a:xfrm>
+          <a:prstGeom prst="rect">
+            <a:avLst/>
+          </a:prstGeom>
+          <a:noFill/>
+        </p:spPr>
+        <p:txBody>
+          <a:bodyPr wrap="square" lIns="0" rIns="0" tIns="0" bIns="0">
+            <a:normAutofit/>
+          </a:bodyPr>
+          <a:lstStyle/>
+          <a:p>
+            <a:pPr algn="l"/>
+            <a:r>
+              <a:rPr sz="1500" b="1">
                 <a:solidFill>
                   <a:srgbClr val="FFFFFF"/>
                 </a:solidFill>
                 <a:latin typeface="Aptos"/>
               </a:rPr>
-              <a:t>Fundação deliberada</a:t>
-            </a:r>
-          </a:p>
-          <a:p>
-            <a:pPr algn="l"/>
-            <a:r>
-              <a:rPr sz="1800" b="1">
+              <a:t>Fundação aprovada</a:t>
+            </a:r>
+          </a:p>
+          <a:p>
+            <a:pPr algn="l"/>
+            <a:r>
+              <a:rPr sz="1500" b="1">
                 <a:solidFill>
                   <a:srgbClr val="FFFFFF"/>
                 </a:solidFill>
@@ -3343,49 +3380,49 @@
       </p:sp>
       <p:sp>
         <p:nvSpPr>
-          <p:cNvPr id="8" name="TextBox 7"/>
-          <p:cNvSpPr txBox="1"/>
-          <p:nvPr/>
-        </p:nvSpPr>
-        <p:spPr>
-          <a:xfrm>
-            <a:off x="8138160" y="3108960"/>
-            <a:ext cx="2377440" cy="1371600"/>
-          </a:xfrm>
-          <a:prstGeom prst="rect">
-            <a:avLst/>
-          </a:prstGeom>
-          <a:noFill/>
-        </p:spPr>
-        <p:txBody>
-          <a:bodyPr wrap="square" lIns="0" rIns="0" tIns="0" bIns="0">
-            <a:normAutofit/>
-          </a:bodyPr>
-          <a:lstStyle/>
-          <a:p>
-            <a:pPr algn="l"/>
-            <a:r>
-              <a:rPr sz="1600" b="0">
+          <p:cNvPr id="9" name="TextBox 8"/>
+          <p:cNvSpPr txBox="1"/>
+          <p:nvPr/>
+        </p:nvSpPr>
+        <p:spPr>
+          <a:xfrm>
+            <a:off x="8485632" y="2761488"/>
+            <a:ext cx="1993392" cy="914400"/>
+          </a:xfrm>
+          <a:prstGeom prst="rect">
+            <a:avLst/>
+          </a:prstGeom>
+          <a:noFill/>
+        </p:spPr>
+        <p:txBody>
+          <a:bodyPr wrap="square" lIns="0" rIns="0" tIns="0" bIns="0">
+            <a:normAutofit/>
+          </a:bodyPr>
+          <a:lstStyle/>
+          <a:p>
+            <a:pPr algn="l"/>
+            <a:r>
+              <a:rPr sz="1300" b="0">
                 <a:solidFill>
                   <a:srgbClr val="FFFFFF"/>
                 </a:solidFill>
                 <a:latin typeface="Aptos"/>
               </a:rPr>
-              <a:t>26 Oficiais de Chancelaria reunidos em Brasília decidiram criar uma entidade própria e juridicamente independente.</a:t>
-            </a:r>
-          </a:p>
-        </p:txBody>
-      </p:sp>
-      <p:sp>
-        <p:nvSpPr>
-          <p:cNvPr id="9" name="TextBox 8"/>
-          <p:cNvSpPr txBox="1"/>
-          <p:nvPr/>
-        </p:nvSpPr>
-        <p:spPr>
-          <a:xfrm>
-            <a:off x="8138160" y="4800600"/>
-            <a:ext cx="1828800" cy="274320"/>
+              <a:t>26 Oficiais de Chancelaria, reunidos em Brasília, decidiram criar uma entidade própria e independente.</a:t>
+            </a:r>
+          </a:p>
+        </p:txBody>
+      </p:sp>
+      <p:sp>
+        <p:nvSpPr>
+          <p:cNvPr id="10" name="TextBox 9"/>
+          <p:cNvSpPr txBox="1"/>
+          <p:nvPr/>
+        </p:nvSpPr>
+        <p:spPr>
+          <a:xfrm>
+            <a:off x="8485632" y="3977639"/>
+            <a:ext cx="1371600" cy="201168"/>
           </a:xfrm>
           <a:prstGeom prst="rect">
             <a:avLst/>
@@ -3413,49 +3450,49 @@
       </p:sp>
       <p:sp>
         <p:nvSpPr>
-          <p:cNvPr id="10" name="TextBox 9"/>
-          <p:cNvSpPr txBox="1"/>
-          <p:nvPr/>
-        </p:nvSpPr>
-        <p:spPr>
-          <a:xfrm>
-            <a:off x="8138160" y="5074920"/>
-            <a:ext cx="2468880" cy="640080"/>
-          </a:xfrm>
-          <a:prstGeom prst="rect">
-            <a:avLst/>
-          </a:prstGeom>
-          <a:noFill/>
-        </p:spPr>
-        <p:txBody>
-          <a:bodyPr wrap="square" lIns="0" rIns="0" tIns="0" bIns="0">
-            <a:normAutofit/>
-          </a:bodyPr>
-          <a:lstStyle/>
-          <a:p>
-            <a:pPr algn="l"/>
-            <a:r>
-              <a:rPr sz="1500" b="1">
+          <p:cNvPr id="11" name="TextBox 10"/>
+          <p:cNvSpPr txBox="1"/>
+          <p:nvPr/>
+        </p:nvSpPr>
+        <p:spPr>
+          <a:xfrm>
+            <a:off x="8485632" y="4224528"/>
+            <a:ext cx="1993392" cy="502920"/>
+          </a:xfrm>
+          <a:prstGeom prst="rect">
+            <a:avLst/>
+          </a:prstGeom>
+          <a:noFill/>
+        </p:spPr>
+        <p:txBody>
+          <a:bodyPr wrap="square" lIns="0" rIns="0" tIns="0" bIns="0">
+            <a:normAutofit/>
+          </a:bodyPr>
+          <a:lstStyle/>
+          <a:p>
+            <a:pPr algn="l"/>
+            <a:r>
+              <a:rPr sz="1300" b="1">
                 <a:solidFill>
                   <a:srgbClr val="FFFFFF"/>
                 </a:solidFill>
                 <a:latin typeface="Aptos"/>
               </a:rPr>
-              <a:t>A ASOF une representação institucional e apoio prático ao associado.</a:t>
-            </a:r>
-          </a:p>
-        </p:txBody>
-      </p:sp>
-      <p:sp>
-        <p:nvSpPr>
-          <p:cNvPr id="11" name="TextBox 10"/>
-          <p:cNvSpPr txBox="1"/>
-          <p:nvPr/>
-        </p:nvSpPr>
-        <p:spPr>
-          <a:xfrm>
-            <a:off x="10881360" y="6400800"/>
-            <a:ext cx="640080" cy="228600"/>
+              <a:t>Representação institucional com apoio prático ao associado.</a:t>
+            </a:r>
+          </a:p>
+        </p:txBody>
+      </p:sp>
+      <p:sp>
+        <p:nvSpPr>
+          <p:cNvPr id="12" name="TextBox 11"/>
+          <p:cNvSpPr txBox="1"/>
+          <p:nvPr/>
+        </p:nvSpPr>
+        <p:spPr>
+          <a:xfrm>
+            <a:off x="10808208" y="6144768"/>
+            <a:ext cx="713232" cy="228600"/>
           </a:xfrm>
           <a:prstGeom prst="rect">
             <a:avLst/>
@@ -3476,7 +3513,7 @@
                 </a:solidFill>
                 <a:latin typeface="Aptos"/>
               </a:rPr>
-              <a:t>01 / 14</a:t>
+              <a:t>01 / 16</a:t>
             </a:r>
           </a:p>
         </p:txBody>
@@ -4035,8 +4072,8 @@
         </p:nvSpPr>
         <p:spPr>
           <a:xfrm>
-            <a:off x="10881360" y="6400800"/>
-            <a:ext cx="640080" cy="228600"/>
+            <a:off x="10808208" y="6144768"/>
+            <a:ext cx="713232" cy="228600"/>
           </a:xfrm>
           <a:prstGeom prst="rect">
             <a:avLst/>
@@ -4057,7 +4094,7 @@
                 </a:solidFill>
                 <a:latin typeface="Aptos"/>
               </a:rPr>
-              <a:t>10 / 14</a:t>
+              <a:t>10 / 16</a:t>
             </a:r>
           </a:p>
         </p:txBody>
@@ -4071,6 +4108,299 @@
 </file>
 
 <file path=ppt/slides/slide11.xml><?xml version="1.0" encoding="utf-8"?>
+<p:sld xmlns:a="http://schemas.openxmlformats.org/drawingml/2006/main" xmlns:p="http://schemas.openxmlformats.org/presentationml/2006/main" xmlns:r="http://schemas.openxmlformats.org/officeDocument/2006/relationships">
+  <p:cSld>
+    <p:bg>
+      <p:bgPr>
+        <a:solidFill>
+          <a:srgbClr val="1E2761"/>
+        </a:solidFill>
+        <a:effectLst/>
+      </p:bgPr>
+    </p:bg>
+    <p:spTree>
+      <p:nvGrpSpPr>
+        <p:cNvPr id="1" name=""/>
+        <p:cNvGrpSpPr/>
+        <p:nvPr/>
+      </p:nvGrpSpPr>
+      <p:grpSpPr/>
+      <p:sp>
+        <p:nvSpPr>
+          <p:cNvPr id="2" name="TextBox 1"/>
+          <p:cNvSpPr txBox="1"/>
+          <p:nvPr/>
+        </p:nvSpPr>
+        <p:spPr>
+          <a:xfrm>
+            <a:off x="822960" y="914400"/>
+            <a:ext cx="3200400" cy="320040"/>
+          </a:xfrm>
+          <a:prstGeom prst="rect">
+            <a:avLst/>
+          </a:prstGeom>
+          <a:noFill/>
+        </p:spPr>
+        <p:txBody>
+          <a:bodyPr wrap="square" lIns="0" rIns="0" tIns="0" bIns="0">
+            <a:normAutofit/>
+          </a:bodyPr>
+          <a:lstStyle/>
+          <a:p>
+            <a:pPr algn="l"/>
+            <a:r>
+              <a:rPr sz="1400" b="1">
+                <a:solidFill>
+                  <a:srgbClr val="F9E795"/>
+                </a:solidFill>
+                <a:latin typeface="Aptos"/>
+              </a:rPr>
+              <a:t>APÊNDICE</a:t>
+            </a:r>
+          </a:p>
+        </p:txBody>
+      </p:sp>
+      <p:sp>
+        <p:nvSpPr>
+          <p:cNvPr id="3" name="TextBox 2"/>
+          <p:cNvSpPr txBox="1"/>
+          <p:nvPr/>
+        </p:nvSpPr>
+        <p:spPr>
+          <a:xfrm>
+            <a:off x="822960" y="1463040"/>
+            <a:ext cx="6858000" cy="914400"/>
+          </a:xfrm>
+          <a:prstGeom prst="rect">
+            <a:avLst/>
+          </a:prstGeom>
+          <a:noFill/>
+        </p:spPr>
+        <p:txBody>
+          <a:bodyPr wrap="square" lIns="0" rIns="0" tIns="0" bIns="0">
+            <a:normAutofit/>
+          </a:bodyPr>
+          <a:lstStyle/>
+          <a:p>
+            <a:pPr algn="l"/>
+            <a:r>
+              <a:rPr sz="3100" b="1">
+                <a:solidFill>
+                  <a:srgbClr val="FFFFFF"/>
+                </a:solidFill>
+                <a:latin typeface="Aptos Display"/>
+              </a:rPr>
+              <a:t>Lista completa dos convênios</a:t>
+            </a:r>
+          </a:p>
+        </p:txBody>
+      </p:sp>
+      <p:sp>
+        <p:nvSpPr>
+          <p:cNvPr id="4" name="TextBox 3"/>
+          <p:cNvSpPr txBox="1"/>
+          <p:nvPr/>
+        </p:nvSpPr>
+        <p:spPr>
+          <a:xfrm>
+            <a:off x="822960" y="2743200"/>
+            <a:ext cx="5669280" cy="731520"/>
+          </a:xfrm>
+          <a:prstGeom prst="rect">
+            <a:avLst/>
+          </a:prstGeom>
+          <a:noFill/>
+        </p:spPr>
+        <p:txBody>
+          <a:bodyPr wrap="square" lIns="0" rIns="0" tIns="0" bIns="0">
+            <a:normAutofit/>
+          </a:bodyPr>
+          <a:lstStyle/>
+          <a:p>
+            <a:pPr algn="l"/>
+            <a:r>
+              <a:rPr sz="1800" b="0">
+                <a:solidFill>
+                  <a:srgbClr val="CADCFC"/>
+                </a:solidFill>
+                <a:latin typeface="Aptos"/>
+              </a:rPr>
+              <a:t>Os slides a seguir organizam os parceiros por categoria, com foco em consulta rápida e melhor legibilidade.</a:t>
+            </a:r>
+          </a:p>
+        </p:txBody>
+      </p:sp>
+      <p:sp>
+        <p:nvSpPr>
+          <p:cNvPr id="5" name="Rounded Rectangle 4"/>
+          <p:cNvSpPr/>
+          <p:nvPr/>
+        </p:nvSpPr>
+        <p:spPr>
+          <a:xfrm>
+            <a:off x="8046720" y="1097280"/>
+            <a:ext cx="2560320" cy="4206240"/>
+          </a:xfrm>
+          <a:prstGeom prst="roundRect">
+            <a:avLst/>
+          </a:prstGeom>
+          <a:solidFill>
+            <a:srgbClr val="065A82"/>
+          </a:solidFill>
+          <a:ln>
+            <a:solidFill>
+              <a:srgbClr val="065A82"/>
+            </a:solidFill>
+          </a:ln>
+        </p:spPr>
+        <p:style>
+          <a:lnRef idx="1">
+            <a:schemeClr val="accent1"/>
+          </a:lnRef>
+          <a:fillRef idx="3">
+            <a:schemeClr val="accent1"/>
+          </a:fillRef>
+          <a:effectRef idx="2">
+            <a:schemeClr val="accent1"/>
+          </a:effectRef>
+          <a:fontRef idx="minor">
+            <a:schemeClr val="lt1"/>
+          </a:fontRef>
+        </p:style>
+        <p:txBody>
+          <a:bodyPr rtlCol="0" anchor="ctr"/>
+          <a:lstStyle/>
+          <a:p>
+            <a:pPr algn="ctr"/>
+          </a:p>
+        </p:txBody>
+      </p:sp>
+      <p:sp>
+        <p:nvSpPr>
+          <p:cNvPr id="6" name="TextBox 5"/>
+          <p:cNvSpPr txBox="1"/>
+          <p:nvPr/>
+        </p:nvSpPr>
+        <p:spPr>
+          <a:xfrm>
+            <a:off x="8366760" y="1828800"/>
+            <a:ext cx="1920240" cy="822960"/>
+          </a:xfrm>
+          <a:prstGeom prst="rect">
+            <a:avLst/>
+          </a:prstGeom>
+          <a:noFill/>
+        </p:spPr>
+        <p:txBody>
+          <a:bodyPr wrap="square" lIns="0" rIns="0" tIns="0" bIns="0">
+            <a:normAutofit/>
+          </a:bodyPr>
+          <a:lstStyle/>
+          <a:p>
+            <a:pPr algn="ctr"/>
+            <a:r>
+              <a:rPr sz="2800" b="1">
+                <a:solidFill>
+                  <a:srgbClr val="FFFFFF"/>
+                </a:solidFill>
+                <a:latin typeface="Aptos Display"/>
+              </a:rPr>
+              <a:t>Catálogo</a:t>
+            </a:r>
+          </a:p>
+          <a:p>
+            <a:pPr algn="ctr"/>
+            <a:r>
+              <a:rPr sz="2800" b="1">
+                <a:solidFill>
+                  <a:srgbClr val="FFFFFF"/>
+                </a:solidFill>
+                <a:latin typeface="Aptos Display"/>
+              </a:rPr>
+              <a:t>completo</a:t>
+            </a:r>
+          </a:p>
+        </p:txBody>
+      </p:sp>
+      <p:sp>
+        <p:nvSpPr>
+          <p:cNvPr id="7" name="TextBox 6"/>
+          <p:cNvSpPr txBox="1"/>
+          <p:nvPr/>
+        </p:nvSpPr>
+        <p:spPr>
+          <a:xfrm>
+            <a:off x="8412480" y="3246120"/>
+            <a:ext cx="1828800" cy="1280160"/>
+          </a:xfrm>
+          <a:prstGeom prst="rect">
+            <a:avLst/>
+          </a:prstGeom>
+          <a:noFill/>
+        </p:spPr>
+        <p:txBody>
+          <a:bodyPr wrap="square" lIns="0" rIns="0" tIns="0" bIns="0">
+            <a:normAutofit/>
+          </a:bodyPr>
+          <a:lstStyle/>
+          <a:p>
+            <a:pPr algn="ctr"/>
+            <a:r>
+              <a:rPr sz="1400" b="0">
+                <a:solidFill>
+                  <a:srgbClr val="FFFFFF"/>
+                </a:solidFill>
+                <a:latin typeface="Aptos"/>
+              </a:rPr>
+              <a:t>Listas por categoria para consulta rápida durante o onboard ou como anexo de apoio.</a:t>
+            </a:r>
+          </a:p>
+        </p:txBody>
+      </p:sp>
+      <p:sp>
+        <p:nvSpPr>
+          <p:cNvPr id="8" name="TextBox 7"/>
+          <p:cNvSpPr txBox="1"/>
+          <p:nvPr/>
+        </p:nvSpPr>
+        <p:spPr>
+          <a:xfrm>
+            <a:off x="10808208" y="6144768"/>
+            <a:ext cx="713232" cy="228600"/>
+          </a:xfrm>
+          <a:prstGeom prst="rect">
+            <a:avLst/>
+          </a:prstGeom>
+          <a:noFill/>
+        </p:spPr>
+        <p:txBody>
+          <a:bodyPr wrap="square" lIns="0" rIns="0" tIns="0" bIns="0">
+            <a:normAutofit/>
+          </a:bodyPr>
+          <a:lstStyle/>
+          <a:p>
+            <a:pPr algn="r"/>
+            <a:r>
+              <a:rPr sz="1000" b="0">
+                <a:solidFill>
+                  <a:srgbClr val="CADCFC"/>
+                </a:solidFill>
+                <a:latin typeface="Aptos"/>
+              </a:rPr>
+              <a:t>11 / 16</a:t>
+            </a:r>
+          </a:p>
+        </p:txBody>
+      </p:sp>
+    </p:spTree>
+  </p:cSld>
+  <p:clrMapOvr>
+    <a:masterClrMapping/>
+  </p:clrMapOvr>
+</p:sld>
+</file>
+
+<file path=ppt/slides/slide12.xml><?xml version="1.0" encoding="utf-8"?>
 <p:sld xmlns:a="http://schemas.openxmlformats.org/drawingml/2006/main" xmlns:p="http://schemas.openxmlformats.org/presentationml/2006/main" xmlns:r="http://schemas.openxmlformats.org/officeDocument/2006/relationships">
   <p:cSld>
     <p:bg>
@@ -4167,7 +4497,7 @@
         <p:spPr>
           <a:xfrm>
             <a:off x="731520" y="1600200"/>
-            <a:ext cx="6400800" cy="457200"/>
+            <a:ext cx="6400800" cy="411480"/>
           </a:xfrm>
           <a:prstGeom prst="rect">
             <a:avLst/>
@@ -4188,7 +4518,7 @@
                 </a:solidFill>
                 <a:latin typeface="Aptos"/>
               </a:rPr>
-              <a:t>Lista dos parceiros identificados no acervo consultado para a frente de educação.</a:t>
+              <a:t>Parceiros identificados no acervo consultado para a frente de educação.</a:t>
             </a:r>
           </a:p>
         </p:txBody>
@@ -4201,8 +4531,8 @@
         </p:nvSpPr>
         <p:spPr>
           <a:xfrm>
-            <a:off x="777240" y="2331720"/>
-            <a:ext cx="3474720" cy="3474720"/>
+            <a:off x="777240" y="2240280"/>
+            <a:ext cx="3474720" cy="3566160"/>
           </a:xfrm>
           <a:prstGeom prst="roundRect">
             <a:avLst/>
@@ -4240,14 +4570,180 @@
       </p:sp>
       <p:sp>
         <p:nvSpPr>
-          <p:cNvPr id="6" name="Rounded Rectangle 5"/>
+          <p:cNvPr id="6" name="TextBox 5"/>
+          <p:cNvSpPr txBox="1"/>
+          <p:nvPr/>
+        </p:nvSpPr>
+        <p:spPr>
+          <a:xfrm>
+            <a:off x="978408" y="2441448"/>
+            <a:ext cx="3072384" cy="256032"/>
+          </a:xfrm>
+          <a:prstGeom prst="rect">
+            <a:avLst/>
+          </a:prstGeom>
+          <a:noFill/>
+        </p:spPr>
+        <p:txBody>
+          <a:bodyPr wrap="square" lIns="0" rIns="0" tIns="0" bIns="0">
+            <a:normAutofit/>
+          </a:bodyPr>
+          <a:lstStyle/>
+          <a:p>
+            <a:pPr algn="l"/>
+            <a:r>
+              <a:rPr sz="1600" b="1">
+                <a:solidFill>
+                  <a:srgbClr val="1E2761"/>
+                </a:solidFill>
+                <a:latin typeface="Aptos"/>
+              </a:rPr>
+              <a:t>Educação 1</a:t>
+            </a:r>
+          </a:p>
+        </p:txBody>
+      </p:sp>
+      <p:sp>
+        <p:nvSpPr>
+          <p:cNvPr id="7" name="TextBox 6"/>
+          <p:cNvSpPr txBox="1"/>
+          <p:nvPr/>
+        </p:nvSpPr>
+        <p:spPr>
+          <a:xfrm>
+            <a:off x="978408" y="2807208"/>
+            <a:ext cx="3072384" cy="2798064"/>
+          </a:xfrm>
+          <a:prstGeom prst="rect">
+            <a:avLst/>
+          </a:prstGeom>
+          <a:noFill/>
+        </p:spPr>
+        <p:txBody>
+          <a:bodyPr wrap="square" lIns="0" rIns="0" tIns="0" bIns="0">
+            <a:normAutofit/>
+          </a:bodyPr>
+          <a:lstStyle/>
+          <a:p>
+            <a:pPr algn="l"/>
+            <a:r>
+              <a:rPr sz="1300" b="0">
+                <a:solidFill>
+                  <a:srgbClr val="1A1A1A"/>
+                </a:solidFill>
+                <a:latin typeface="Aptos"/>
+              </a:rPr>
+              <a:t>Aliança Francesa</a:t>
+            </a:r>
+          </a:p>
+          <a:p>
+            <a:pPr algn="l"/>
+            <a:r>
+              <a:rPr sz="1300" b="0">
+                <a:solidFill>
+                  <a:srgbClr val="1A1A1A"/>
+                </a:solidFill>
+                <a:latin typeface="Aptos"/>
+              </a:rPr>
+              <a:t>CCAA</a:t>
+            </a:r>
+          </a:p>
+          <a:p>
+            <a:pPr algn="l"/>
+            <a:r>
+              <a:rPr sz="1300" b="0">
+                <a:solidFill>
+                  <a:srgbClr val="1A1A1A"/>
+                </a:solidFill>
+                <a:latin typeface="Aptos"/>
+              </a:rPr>
+              <a:t>CIMAN</a:t>
+            </a:r>
+          </a:p>
+          <a:p>
+            <a:pPr algn="l"/>
+            <a:r>
+              <a:rPr sz="1300" b="0">
+                <a:solidFill>
+                  <a:srgbClr val="1A1A1A"/>
+                </a:solidFill>
+                <a:latin typeface="Aptos"/>
+              </a:rPr>
+              <a:t>Colégio Dinatos COC</a:t>
+            </a:r>
+          </a:p>
+          <a:p>
+            <a:pPr algn="l"/>
+            <a:r>
+              <a:rPr sz="1300" b="0">
+                <a:solidFill>
+                  <a:srgbClr val="1A1A1A"/>
+                </a:solidFill>
+                <a:latin typeface="Aptos"/>
+              </a:rPr>
+              <a:t>Cultura Inglesa</a:t>
+            </a:r>
+          </a:p>
+          <a:p>
+            <a:pPr algn="l"/>
+            <a:r>
+              <a:rPr sz="1300" b="0">
+                <a:solidFill>
+                  <a:srgbClr val="1A1A1A"/>
+                </a:solidFill>
+                <a:latin typeface="Aptos"/>
+              </a:rPr>
+              <a:t>Curso Ignis</a:t>
+            </a:r>
+          </a:p>
+          <a:p>
+            <a:pPr algn="l"/>
+            <a:r>
+              <a:rPr sz="1300" b="0">
+                <a:solidFill>
+                  <a:srgbClr val="1A1A1A"/>
+                </a:solidFill>
+                <a:latin typeface="Aptos"/>
+              </a:rPr>
+              <a:t>Escola Franciscana Fátima</a:t>
+            </a:r>
+          </a:p>
+          <a:p>
+            <a:pPr algn="l"/>
+            <a:r>
+              <a:rPr sz="1300" b="0">
+                <a:solidFill>
+                  <a:srgbClr val="1A1A1A"/>
+                </a:solidFill>
+                <a:latin typeface="Aptos"/>
+              </a:rPr>
+              <a:t>Escola Presbiteriana Mackenzie</a:t>
+            </a:r>
+          </a:p>
+          <a:p>
+            <a:pPr algn="l"/>
+            <a:r>
+              <a:rPr sz="1300" b="0">
+                <a:solidFill>
+                  <a:srgbClr val="1A1A1A"/>
+                </a:solidFill>
+                <a:latin typeface="Aptos"/>
+              </a:rPr>
+              <a:t>FACITEC</a:t>
+            </a:r>
+          </a:p>
+        </p:txBody>
+      </p:sp>
+      <p:sp>
+        <p:nvSpPr>
+          <p:cNvPr id="8" name="Rounded Rectangle 7"/>
           <p:cNvSpPr/>
           <p:nvPr/>
         </p:nvSpPr>
         <p:spPr>
           <a:xfrm>
-            <a:off x="4434840" y="2331720"/>
-            <a:ext cx="3474720" cy="3474720"/>
+            <a:off x="4434840" y="2240280"/>
+            <a:ext cx="3474720" cy="3566160"/>
           </a:xfrm>
           <a:prstGeom prst="roundRect">
             <a:avLst/>
@@ -4285,14 +4781,180 @@
       </p:sp>
       <p:sp>
         <p:nvSpPr>
-          <p:cNvPr id="7" name="Rounded Rectangle 6"/>
+          <p:cNvPr id="9" name="TextBox 8"/>
+          <p:cNvSpPr txBox="1"/>
+          <p:nvPr/>
+        </p:nvSpPr>
+        <p:spPr>
+          <a:xfrm>
+            <a:off x="4636008" y="2441448"/>
+            <a:ext cx="3072384" cy="256032"/>
+          </a:xfrm>
+          <a:prstGeom prst="rect">
+            <a:avLst/>
+          </a:prstGeom>
+          <a:noFill/>
+        </p:spPr>
+        <p:txBody>
+          <a:bodyPr wrap="square" lIns="0" rIns="0" tIns="0" bIns="0">
+            <a:normAutofit/>
+          </a:bodyPr>
+          <a:lstStyle/>
+          <a:p>
+            <a:pPr algn="l"/>
+            <a:r>
+              <a:rPr sz="1600" b="1">
+                <a:solidFill>
+                  <a:srgbClr val="1E2761"/>
+                </a:solidFill>
+                <a:latin typeface="Aptos"/>
+              </a:rPr>
+              <a:t>Educação 2</a:t>
+            </a:r>
+          </a:p>
+        </p:txBody>
+      </p:sp>
+      <p:sp>
+        <p:nvSpPr>
+          <p:cNvPr id="10" name="TextBox 9"/>
+          <p:cNvSpPr txBox="1"/>
+          <p:nvPr/>
+        </p:nvSpPr>
+        <p:spPr>
+          <a:xfrm>
+            <a:off x="4636008" y="2807208"/>
+            <a:ext cx="3072384" cy="2798064"/>
+          </a:xfrm>
+          <a:prstGeom prst="rect">
+            <a:avLst/>
+          </a:prstGeom>
+          <a:noFill/>
+        </p:spPr>
+        <p:txBody>
+          <a:bodyPr wrap="square" lIns="0" rIns="0" tIns="0" bIns="0">
+            <a:normAutofit/>
+          </a:bodyPr>
+          <a:lstStyle/>
+          <a:p>
+            <a:pPr algn="l"/>
+            <a:r>
+              <a:rPr sz="1300" b="0">
+                <a:solidFill>
+                  <a:srgbClr val="1A1A1A"/>
+                </a:solidFill>
+                <a:latin typeface="Aptos"/>
+              </a:rPr>
+              <a:t>FGV</a:t>
+            </a:r>
+          </a:p>
+          <a:p>
+            <a:pPr algn="l"/>
+            <a:r>
+              <a:rPr sz="1300" b="0">
+                <a:solidFill>
+                  <a:srgbClr val="1A1A1A"/>
+                </a:solidFill>
+                <a:latin typeface="Aptos"/>
+              </a:rPr>
+              <a:t>Gran Cursos</a:t>
+            </a:r>
+          </a:p>
+          <a:p>
+            <a:pPr algn="l"/>
+            <a:r>
+              <a:rPr sz="1300" b="0">
+                <a:solidFill>
+                  <a:srgbClr val="1A1A1A"/>
+                </a:solidFill>
+                <a:latin typeface="Aptos"/>
+              </a:rPr>
+              <a:t>IBMEC</a:t>
+            </a:r>
+          </a:p>
+          <a:p>
+            <a:pPr algn="l"/>
+            <a:r>
+              <a:rPr sz="1300" b="0">
+                <a:solidFill>
+                  <a:srgbClr val="1A1A1A"/>
+                </a:solidFill>
+                <a:latin typeface="Aptos"/>
+              </a:rPr>
+              <a:t>IDP</a:t>
+            </a:r>
+          </a:p>
+          <a:p>
+            <a:pPr algn="l"/>
+            <a:r>
+              <a:rPr sz="1300" b="0">
+                <a:solidFill>
+                  <a:srgbClr val="1A1A1A"/>
+                </a:solidFill>
+                <a:latin typeface="Aptos"/>
+              </a:rPr>
+              <a:t>IESB</a:t>
+            </a:r>
+          </a:p>
+          <a:p>
+            <a:pPr algn="l"/>
+            <a:r>
+              <a:rPr sz="1300" b="0">
+                <a:solidFill>
+                  <a:srgbClr val="1A1A1A"/>
+                </a:solidFill>
+                <a:latin typeface="Aptos"/>
+              </a:rPr>
+              <a:t>Instituto Blaise Pascal</a:t>
+            </a:r>
+          </a:p>
+          <a:p>
+            <a:pPr algn="l"/>
+            <a:r>
+              <a:rPr sz="1300" b="0">
+                <a:solidFill>
+                  <a:srgbClr val="1A1A1A"/>
+                </a:solidFill>
+                <a:latin typeface="Aptos"/>
+              </a:rPr>
+              <a:t>Laboro</a:t>
+            </a:r>
+          </a:p>
+          <a:p>
+            <a:pPr algn="l"/>
+            <a:r>
+              <a:rPr sz="1300" b="0">
+                <a:solidFill>
+                  <a:srgbClr val="1A1A1A"/>
+                </a:solidFill>
+                <a:latin typeface="Aptos"/>
+              </a:rPr>
+              <a:t>MS Educação</a:t>
+            </a:r>
+          </a:p>
+          <a:p>
+            <a:pPr algn="l"/>
+            <a:r>
+              <a:rPr sz="1300" b="0">
+                <a:solidFill>
+                  <a:srgbClr val="1A1A1A"/>
+                </a:solidFill>
+                <a:latin typeface="Aptos"/>
+              </a:rPr>
+              <a:t>Positive Idiomas</a:t>
+            </a:r>
+          </a:p>
+        </p:txBody>
+      </p:sp>
+      <p:sp>
+        <p:nvSpPr>
+          <p:cNvPr id="11" name="Rounded Rectangle 10"/>
           <p:cNvSpPr/>
           <p:nvPr/>
         </p:nvSpPr>
         <p:spPr>
           <a:xfrm>
-            <a:off x="8092440" y="2331720"/>
-            <a:ext cx="3291840" cy="3474720"/>
+            <a:off x="8092440" y="2240280"/>
+            <a:ext cx="3291840" cy="3566160"/>
           </a:xfrm>
           <a:prstGeom prst="roundRect">
             <a:avLst/>
@@ -4330,392 +4992,165 @@
       </p:sp>
       <p:sp>
         <p:nvSpPr>
-          <p:cNvPr id="8" name="TextBox 7"/>
-          <p:cNvSpPr txBox="1"/>
-          <p:nvPr/>
-        </p:nvSpPr>
-        <p:spPr>
-          <a:xfrm>
-            <a:off x="1005840" y="2697480"/>
-            <a:ext cx="2834640" cy="2651760"/>
-          </a:xfrm>
-          <a:prstGeom prst="rect">
-            <a:avLst/>
-          </a:prstGeom>
-          <a:noFill/>
-        </p:spPr>
-        <p:txBody>
-          <a:bodyPr wrap="square" lIns="0" rIns="0" tIns="0" bIns="0">
-            <a:normAutofit/>
-          </a:bodyPr>
-          <a:lstStyle/>
-          <a:p>
-            <a:pPr algn="l"/>
-            <a:r>
-              <a:rPr sz="1600" b="0">
+          <p:cNvPr id="12" name="TextBox 11"/>
+          <p:cNvSpPr txBox="1"/>
+          <p:nvPr/>
+        </p:nvSpPr>
+        <p:spPr>
+          <a:xfrm>
+            <a:off x="8293608" y="2441448"/>
+            <a:ext cx="2889504" cy="256032"/>
+          </a:xfrm>
+          <a:prstGeom prst="rect">
+            <a:avLst/>
+          </a:prstGeom>
+          <a:noFill/>
+        </p:spPr>
+        <p:txBody>
+          <a:bodyPr wrap="square" lIns="0" rIns="0" tIns="0" bIns="0">
+            <a:normAutofit/>
+          </a:bodyPr>
+          <a:lstStyle/>
+          <a:p>
+            <a:pPr algn="l"/>
+            <a:r>
+              <a:rPr sz="1600" b="1">
+                <a:solidFill>
+                  <a:srgbClr val="1E2761"/>
+                </a:solidFill>
+                <a:latin typeface="Aptos"/>
+              </a:rPr>
+              <a:t>Educação 3</a:t>
+            </a:r>
+          </a:p>
+        </p:txBody>
+      </p:sp>
+      <p:sp>
+        <p:nvSpPr>
+          <p:cNvPr id="13" name="TextBox 12"/>
+          <p:cNvSpPr txBox="1"/>
+          <p:nvPr/>
+        </p:nvSpPr>
+        <p:spPr>
+          <a:xfrm>
+            <a:off x="8293608" y="2807208"/>
+            <a:ext cx="2889504" cy="2798064"/>
+          </a:xfrm>
+          <a:prstGeom prst="rect">
+            <a:avLst/>
+          </a:prstGeom>
+          <a:noFill/>
+        </p:spPr>
+        <p:txBody>
+          <a:bodyPr wrap="square" lIns="0" rIns="0" tIns="0" bIns="0">
+            <a:normAutofit/>
+          </a:bodyPr>
+          <a:lstStyle/>
+          <a:p>
+            <a:pPr algn="l"/>
+            <a:r>
+              <a:rPr sz="1300" b="0">
                 <a:solidFill>
                   <a:srgbClr val="1A1A1A"/>
                 </a:solidFill>
                 <a:latin typeface="Aptos"/>
               </a:rPr>
-              <a:t>Aliança Francesa</a:t>
-            </a:r>
-          </a:p>
-          <a:p>
-            <a:pPr algn="l"/>
-            <a:r>
-              <a:rPr sz="1600" b="0">
+              <a:t>Rede de Ensino JK</a:t>
+            </a:r>
+          </a:p>
+          <a:p>
+            <a:pPr algn="l"/>
+            <a:r>
+              <a:rPr sz="1300" b="0">
                 <a:solidFill>
                   <a:srgbClr val="1A1A1A"/>
                 </a:solidFill>
                 <a:latin typeface="Aptos"/>
               </a:rPr>
-              <a:t>CCAA</a:t>
-            </a:r>
-          </a:p>
-          <a:p>
-            <a:pPr algn="l"/>
-            <a:r>
-              <a:rPr sz="1600" b="0">
+              <a:t>St. Giles</a:t>
+            </a:r>
+          </a:p>
+          <a:p>
+            <a:pPr algn="l"/>
+            <a:r>
+              <a:rPr sz="1300" b="0">
                 <a:solidFill>
                   <a:srgbClr val="1A1A1A"/>
                 </a:solidFill>
                 <a:latin typeface="Aptos"/>
               </a:rPr>
-              <a:t>CIMAN</a:t>
-            </a:r>
-          </a:p>
-          <a:p>
-            <a:pPr algn="l"/>
-            <a:r>
-              <a:rPr sz="1600" b="0">
+              <a:t>Studio On-line</a:t>
+            </a:r>
+          </a:p>
+          <a:p>
+            <a:pPr algn="l"/>
+            <a:r>
+              <a:rPr sz="1300" b="0">
                 <a:solidFill>
                   <a:srgbClr val="1A1A1A"/>
                 </a:solidFill>
                 <a:latin typeface="Aptos"/>
               </a:rPr>
-              <a:t>Colégio Dinatos COC</a:t>
-            </a:r>
-          </a:p>
-          <a:p>
-            <a:pPr algn="l"/>
-            <a:r>
-              <a:rPr sz="1600" b="0">
+              <a:t>Swiss International School</a:t>
+            </a:r>
+          </a:p>
+          <a:p>
+            <a:pPr algn="l"/>
+            <a:r>
+              <a:rPr sz="1300" b="0">
                 <a:solidFill>
                   <a:srgbClr val="1A1A1A"/>
                 </a:solidFill>
                 <a:latin typeface="Aptos"/>
               </a:rPr>
-              <a:t>Cultura Inglesa</a:t>
-            </a:r>
-          </a:p>
-          <a:p>
-            <a:pPr algn="l"/>
-            <a:r>
-              <a:rPr sz="1600" b="0">
+              <a:t>Thomas Jefferson</a:t>
+            </a:r>
+          </a:p>
+          <a:p>
+            <a:pPr algn="l"/>
+            <a:r>
+              <a:rPr sz="1300" b="0">
                 <a:solidFill>
                   <a:srgbClr val="1A1A1A"/>
                 </a:solidFill>
                 <a:latin typeface="Aptos"/>
               </a:rPr>
-              <a:t>Curso Ignis</a:t>
-            </a:r>
-          </a:p>
-          <a:p>
-            <a:pPr algn="l"/>
-            <a:r>
-              <a:rPr sz="1600" b="0">
+              <a:t>UDF</a:t>
+            </a:r>
+          </a:p>
+          <a:p>
+            <a:pPr algn="l"/>
+            <a:r>
+              <a:rPr sz="1300" b="0">
                 <a:solidFill>
                   <a:srgbClr val="1A1A1A"/>
                 </a:solidFill>
                 <a:latin typeface="Aptos"/>
               </a:rPr>
-              <a:t>Escola Franciscana Fátima</a:t>
-            </a:r>
-          </a:p>
-          <a:p>
-            <a:pPr algn="l"/>
-            <a:r>
-              <a:rPr sz="1600" b="0">
+              <a:t>UniCEUB</a:t>
+            </a:r>
+          </a:p>
+          <a:p>
+            <a:pPr algn="l"/>
+            <a:r>
+              <a:rPr sz="1300" b="0">
                 <a:solidFill>
                   <a:srgbClr val="1A1A1A"/>
                 </a:solidFill>
                 <a:latin typeface="Aptos"/>
               </a:rPr>
-              <a:t>Escola Presbiteriana Mackenzie</a:t>
-            </a:r>
-          </a:p>
-          <a:p>
-            <a:pPr algn="l"/>
-            <a:r>
-              <a:rPr sz="1600" b="0">
+              <a:t>UNIP</a:t>
+            </a:r>
+          </a:p>
+          <a:p>
+            <a:pPr algn="l"/>
+            <a:r>
+              <a:rPr sz="1300" b="0">
                 <a:solidFill>
                   <a:srgbClr val="1A1A1A"/>
                 </a:solidFill>
                 <a:latin typeface="Aptos"/>
               </a:rPr>
-              <a:t>FACITEC</a:t>
-            </a:r>
-          </a:p>
-        </p:txBody>
-      </p:sp>
-      <p:sp>
-        <p:nvSpPr>
-          <p:cNvPr id="9" name="TextBox 8"/>
-          <p:cNvSpPr txBox="1"/>
-          <p:nvPr/>
-        </p:nvSpPr>
-        <p:spPr>
-          <a:xfrm>
-            <a:off x="4663440" y="2697480"/>
-            <a:ext cx="2743200" cy="2651760"/>
-          </a:xfrm>
-          <a:prstGeom prst="rect">
-            <a:avLst/>
-          </a:prstGeom>
-          <a:noFill/>
-        </p:spPr>
-        <p:txBody>
-          <a:bodyPr wrap="square" lIns="0" rIns="0" tIns="0" bIns="0">
-            <a:normAutofit/>
-          </a:bodyPr>
-          <a:lstStyle/>
-          <a:p>
-            <a:pPr algn="l"/>
-            <a:r>
-              <a:rPr sz="1600" b="0">
-                <a:solidFill>
-                  <a:srgbClr val="1A1A1A"/>
-                </a:solidFill>
-                <a:latin typeface="Aptos"/>
-              </a:rPr>
-              <a:t>FGV</a:t>
-            </a:r>
-          </a:p>
-          <a:p>
-            <a:pPr algn="l"/>
-            <a:r>
-              <a:rPr sz="1600" b="0">
-                <a:solidFill>
-                  <a:srgbClr val="1A1A1A"/>
-                </a:solidFill>
-                <a:latin typeface="Aptos"/>
-              </a:rPr>
-              <a:t>Gran Cursos</a:t>
-            </a:r>
-          </a:p>
-          <a:p>
-            <a:pPr algn="l"/>
-            <a:r>
-              <a:rPr sz="1600" b="0">
-                <a:solidFill>
-                  <a:srgbClr val="1A1A1A"/>
-                </a:solidFill>
-                <a:latin typeface="Aptos"/>
-              </a:rPr>
-              <a:t>IBMEC</a:t>
-            </a:r>
-          </a:p>
-          <a:p>
-            <a:pPr algn="l"/>
-            <a:r>
-              <a:rPr sz="1600" b="0">
-                <a:solidFill>
-                  <a:srgbClr val="1A1A1A"/>
-                </a:solidFill>
-                <a:latin typeface="Aptos"/>
-              </a:rPr>
-              <a:t>IDP</a:t>
-            </a:r>
-          </a:p>
-          <a:p>
-            <a:pPr algn="l"/>
-            <a:r>
-              <a:rPr sz="1600" b="0">
-                <a:solidFill>
-                  <a:srgbClr val="1A1A1A"/>
-                </a:solidFill>
-                <a:latin typeface="Aptos"/>
-              </a:rPr>
-              <a:t>IESB</a:t>
-            </a:r>
-          </a:p>
-          <a:p>
-            <a:pPr algn="l"/>
-            <a:r>
-              <a:rPr sz="1600" b="0">
-                <a:solidFill>
-                  <a:srgbClr val="1A1A1A"/>
-                </a:solidFill>
-                <a:latin typeface="Aptos"/>
-              </a:rPr>
-              <a:t>Instituto Blaise Pascal</a:t>
-            </a:r>
-          </a:p>
-          <a:p>
-            <a:pPr algn="l"/>
-            <a:r>
-              <a:rPr sz="1600" b="0">
-                <a:solidFill>
-                  <a:srgbClr val="1A1A1A"/>
-                </a:solidFill>
-                <a:latin typeface="Aptos"/>
-              </a:rPr>
-              <a:t>Laboro</a:t>
-            </a:r>
-          </a:p>
-          <a:p>
-            <a:pPr algn="l"/>
-            <a:r>
-              <a:rPr sz="1600" b="0">
-                <a:solidFill>
-                  <a:srgbClr val="1A1A1A"/>
-                </a:solidFill>
-                <a:latin typeface="Aptos"/>
-              </a:rPr>
-              <a:t>MS Educação</a:t>
-            </a:r>
-          </a:p>
-          <a:p>
-            <a:pPr algn="l"/>
-            <a:r>
-              <a:rPr sz="1600" b="0">
-                <a:solidFill>
-                  <a:srgbClr val="1A1A1A"/>
-                </a:solidFill>
-                <a:latin typeface="Aptos"/>
-              </a:rPr>
-              <a:t>Positive Idiomas</a:t>
-            </a:r>
-          </a:p>
-        </p:txBody>
-      </p:sp>
-      <p:sp>
-        <p:nvSpPr>
-          <p:cNvPr id="10" name="TextBox 9"/>
-          <p:cNvSpPr txBox="1"/>
-          <p:nvPr/>
-        </p:nvSpPr>
-        <p:spPr>
-          <a:xfrm>
-            <a:off x="8321040" y="2697480"/>
-            <a:ext cx="2651760" cy="2651760"/>
-          </a:xfrm>
-          <a:prstGeom prst="rect">
-            <a:avLst/>
-          </a:prstGeom>
-          <a:noFill/>
-        </p:spPr>
-        <p:txBody>
-          <a:bodyPr wrap="square" lIns="0" rIns="0" tIns="0" bIns="0">
-            <a:normAutofit/>
-          </a:bodyPr>
-          <a:lstStyle/>
-          <a:p>
-            <a:pPr algn="l"/>
-            <a:r>
-              <a:rPr sz="1600" b="0">
-                <a:solidFill>
-                  <a:srgbClr val="1A1A1A"/>
-                </a:solidFill>
-                <a:latin typeface="Aptos"/>
-              </a:rPr>
-              <a:t>Rede de Ensino JK</a:t>
-            </a:r>
-          </a:p>
-          <a:p>
-            <a:pPr algn="l"/>
-            <a:r>
-              <a:rPr sz="1600" b="0">
-                <a:solidFill>
-                  <a:srgbClr val="1A1A1A"/>
-                </a:solidFill>
-                <a:latin typeface="Aptos"/>
-              </a:rPr>
-              <a:t>St. Giles</a:t>
-            </a:r>
-          </a:p>
-          <a:p>
-            <a:pPr algn="l"/>
-            <a:r>
-              <a:rPr sz="1600" b="0">
-                <a:solidFill>
-                  <a:srgbClr val="1A1A1A"/>
-                </a:solidFill>
-                <a:latin typeface="Aptos"/>
-              </a:rPr>
-              <a:t>Studio On-line</a:t>
-            </a:r>
-          </a:p>
-          <a:p>
-            <a:pPr algn="l"/>
-            <a:r>
-              <a:rPr sz="1600" b="0">
-                <a:solidFill>
-                  <a:srgbClr val="1A1A1A"/>
-                </a:solidFill>
-                <a:latin typeface="Aptos"/>
-              </a:rPr>
-              <a:t>Swiss International School</a:t>
-            </a:r>
-          </a:p>
-          <a:p>
-            <a:pPr algn="l"/>
-            <a:r>
-              <a:rPr sz="1600" b="0">
-                <a:solidFill>
-                  <a:srgbClr val="1A1A1A"/>
-                </a:solidFill>
-                <a:latin typeface="Aptos"/>
-              </a:rPr>
-              <a:t>Thomas Jefferson</a:t>
-            </a:r>
-          </a:p>
-          <a:p>
-            <a:pPr algn="l"/>
-            <a:r>
-              <a:rPr sz="1600" b="0">
-                <a:solidFill>
-                  <a:srgbClr val="1A1A1A"/>
-                </a:solidFill>
-                <a:latin typeface="Aptos"/>
-              </a:rPr>
-              <a:t>UDF</a:t>
-            </a:r>
-          </a:p>
-          <a:p>
-            <a:pPr algn="l"/>
-            <a:r>
-              <a:rPr sz="1600" b="0">
-                <a:solidFill>
-                  <a:srgbClr val="1A1A1A"/>
-                </a:solidFill>
-                <a:latin typeface="Aptos"/>
-              </a:rPr>
-              <a:t>UniCEUB</a:t>
-            </a:r>
-          </a:p>
-          <a:p>
-            <a:pPr algn="l"/>
-            <a:r>
-              <a:rPr sz="1600" b="0">
-                <a:solidFill>
-                  <a:srgbClr val="1A1A1A"/>
-                </a:solidFill>
-                <a:latin typeface="Aptos"/>
-              </a:rPr>
-              <a:t>UNIP</a:t>
-            </a:r>
-          </a:p>
-          <a:p>
-            <a:pPr algn="l"/>
-            <a:r>
-              <a:rPr sz="1600" b="0">
-                <a:solidFill>
-                  <a:srgbClr val="1A1A1A"/>
-                </a:solidFill>
-                <a:latin typeface="Aptos"/>
-              </a:rPr>
               <a:t>Wizard</a:t>
             </a:r>
           </a:p>
@@ -4723,14 +5158,165 @@
       </p:sp>
       <p:sp>
         <p:nvSpPr>
-          <p:cNvPr id="11" name="TextBox 10"/>
-          <p:cNvSpPr txBox="1"/>
-          <p:nvPr/>
-        </p:nvSpPr>
-        <p:spPr>
-          <a:xfrm>
-            <a:off x="10881360" y="6400800"/>
-            <a:ext cx="640080" cy="228600"/>
+          <p:cNvPr id="14" name="Rounded Rectangle 13"/>
+          <p:cNvSpPr/>
+          <p:nvPr/>
+        </p:nvSpPr>
+        <p:spPr>
+          <a:xfrm>
+            <a:off x="8092440" y="5989320"/>
+            <a:ext cx="3291840" cy="502920"/>
+          </a:xfrm>
+          <a:prstGeom prst="roundRect">
+            <a:avLst/>
+          </a:prstGeom>
+          <a:solidFill>
+            <a:srgbClr val="065A82"/>
+          </a:solidFill>
+          <a:ln>
+            <a:solidFill>
+              <a:srgbClr val="065A82"/>
+            </a:solidFill>
+          </a:ln>
+        </p:spPr>
+        <p:style>
+          <a:lnRef idx="1">
+            <a:schemeClr val="accent1"/>
+          </a:lnRef>
+          <a:fillRef idx="3">
+            <a:schemeClr val="accent1"/>
+          </a:fillRef>
+          <a:effectRef idx="2">
+            <a:schemeClr val="accent1"/>
+          </a:effectRef>
+          <a:fontRef idx="minor">
+            <a:schemeClr val="lt1"/>
+          </a:fontRef>
+        </p:style>
+        <p:txBody>
+          <a:bodyPr rtlCol="0" anchor="ctr"/>
+          <a:lstStyle/>
+          <a:p>
+            <a:pPr algn="ctr"/>
+          </a:p>
+        </p:txBody>
+      </p:sp>
+      <p:sp>
+        <p:nvSpPr>
+          <p:cNvPr id="15" name="TextBox 14"/>
+          <p:cNvSpPr txBox="1"/>
+          <p:nvPr/>
+        </p:nvSpPr>
+        <p:spPr>
+          <a:xfrm>
+            <a:off x="8293608" y="6190488"/>
+            <a:ext cx="2889504" cy="256032"/>
+          </a:xfrm>
+          <a:prstGeom prst="rect">
+            <a:avLst/>
+          </a:prstGeom>
+          <a:noFill/>
+        </p:spPr>
+        <p:txBody>
+          <a:bodyPr wrap="square" lIns="0" rIns="0" tIns="0" bIns="0">
+            <a:normAutofit/>
+          </a:bodyPr>
+          <a:lstStyle/>
+          <a:p>
+            <a:pPr algn="l"/>
+            <a:r>
+              <a:rPr sz="1600" b="1">
+                <a:solidFill>
+                  <a:srgbClr val="FFFFFF"/>
+                </a:solidFill>
+                <a:latin typeface="Aptos"/>
+              </a:rPr>
+              <a:t>Complementares</a:t>
+            </a:r>
+          </a:p>
+        </p:txBody>
+      </p:sp>
+      <p:sp>
+        <p:nvSpPr>
+          <p:cNvPr id="16" name="TextBox 15"/>
+          <p:cNvSpPr txBox="1"/>
+          <p:nvPr/>
+        </p:nvSpPr>
+        <p:spPr>
+          <a:xfrm>
+            <a:off x="8293608" y="6556248"/>
+            <a:ext cx="2889504" cy="-265176"/>
+          </a:xfrm>
+          <a:prstGeom prst="rect">
+            <a:avLst/>
+          </a:prstGeom>
+          <a:noFill/>
+        </p:spPr>
+        <p:txBody>
+          <a:bodyPr wrap="square" lIns="0" rIns="0" tIns="0" bIns="0">
+            <a:normAutofit/>
+          </a:bodyPr>
+          <a:lstStyle/>
+          <a:p>
+            <a:pPr algn="l"/>
+            <a:r>
+              <a:rPr sz="1300" b="0">
+                <a:solidFill>
+                  <a:srgbClr val="FFFFFF"/>
+                </a:solidFill>
+                <a:latin typeface="Aptos"/>
+              </a:rPr>
+              <a:t>Centro Educacional Maria Auxiliadora</a:t>
+            </a:r>
+          </a:p>
+          <a:p>
+            <a:pPr algn="l"/>
+            <a:r>
+              <a:rPr sz="1300" b="0">
+                <a:solidFill>
+                  <a:srgbClr val="FFFFFF"/>
+                </a:solidFill>
+                <a:latin typeface="Aptos"/>
+              </a:rPr>
+              <a:t>UNYLEYA</a:t>
+            </a:r>
+          </a:p>
+          <a:p>
+            <a:pPr algn="l"/>
+            <a:r>
+              <a:rPr sz="1300" b="0">
+                <a:solidFill>
+                  <a:srgbClr val="FFFFFF"/>
+                </a:solidFill>
+                <a:latin typeface="Aptos"/>
+              </a:rPr>
+              <a:t>Instituto Formação para a Educação</a:t>
+            </a:r>
+          </a:p>
+          <a:p>
+            <a:pPr algn="l"/>
+            <a:r>
+              <a:rPr sz="1300" b="0">
+                <a:solidFill>
+                  <a:srgbClr val="FFFFFF"/>
+                </a:solidFill>
+                <a:latin typeface="Aptos"/>
+              </a:rPr>
+              <a:t>3W Educacional Editora e Cursos</a:t>
+            </a:r>
+          </a:p>
+        </p:txBody>
+      </p:sp>
+      <p:sp>
+        <p:nvSpPr>
+          <p:cNvPr id="17" name="TextBox 16"/>
+          <p:cNvSpPr txBox="1"/>
+          <p:nvPr/>
+        </p:nvSpPr>
+        <p:spPr>
+          <a:xfrm>
+            <a:off x="10808208" y="6144768"/>
+            <a:ext cx="713232" cy="228600"/>
           </a:xfrm>
           <a:prstGeom prst="rect">
             <a:avLst/>
@@ -4751,7 +5337,7 @@
                 </a:solidFill>
                 <a:latin typeface="Aptos"/>
               </a:rPr>
-              <a:t>11 / 14</a:t>
+              <a:t>12 / 16</a:t>
             </a:r>
           </a:p>
         </p:txBody>
@@ -4764,7 +5350,7 @@
 </p:sld>
 </file>
 
-<file path=ppt/slides/slide12.xml><?xml version="1.0" encoding="utf-8"?>
+<file path=ppt/slides/slide13.xml><?xml version="1.0" encoding="utf-8"?>
 <p:sld xmlns:a="http://schemas.openxmlformats.org/drawingml/2006/main" xmlns:p="http://schemas.openxmlformats.org/presentationml/2006/main" xmlns:r="http://schemas.openxmlformats.org/officeDocument/2006/relationships">
   <p:cSld>
     <p:bg>
@@ -4847,7 +5433,7 @@
                 </a:solidFill>
                 <a:latin typeface="Aptos Display"/>
               </a:rPr>
-              <a:t>Convênios de educação complementar e saúde</a:t>
+              <a:t>Convênios de saúde</a:t>
             </a:r>
           </a:p>
         </p:txBody>
@@ -4861,7 +5447,7 @@
         <p:spPr>
           <a:xfrm>
             <a:off x="731520" y="1600200"/>
-            <a:ext cx="7315200" cy="457200"/>
+            <a:ext cx="7498079" cy="411480"/>
           </a:xfrm>
           <a:prstGeom prst="rect">
             <a:avLst/>
@@ -4882,7 +5468,7 @@
                 </a:solidFill>
                 <a:latin typeface="Aptos"/>
               </a:rPr>
-              <a:t>Além da lista principal, o acervo contém parceiros complementares em educação e uma frente extensa de saúde.</a:t>
+              <a:t>Primeira parte da frente de saúde, separada para manter leitura confortável em tela.</a:t>
             </a:r>
           </a:p>
         </p:txBody>
@@ -4895,18 +5481,18 @@
         </p:nvSpPr>
         <p:spPr>
           <a:xfrm>
-            <a:off x="777240" y="2331720"/>
-            <a:ext cx="3108960" cy="3566160"/>
+            <a:off x="777240" y="2240280"/>
+            <a:ext cx="5029200" cy="3977639"/>
           </a:xfrm>
           <a:prstGeom prst="roundRect">
             <a:avLst/>
           </a:prstGeom>
           <a:solidFill>
-            <a:srgbClr val="065A82"/>
+            <a:srgbClr val="F5F8FC"/>
           </a:solidFill>
           <a:ln>
             <a:solidFill>
-              <a:srgbClr val="065A82"/>
+              <a:srgbClr val="F5F8FC"/>
             </a:solidFill>
           </a:ln>
         </p:spPr>
@@ -4940,29 +5526,29 @@
         </p:nvSpPr>
         <p:spPr>
           <a:xfrm>
-            <a:off x="1005840" y="2651760"/>
-            <a:ext cx="2560320" cy="274320"/>
-          </a:xfrm>
-          <a:prstGeom prst="rect">
-            <a:avLst/>
-          </a:prstGeom>
-          <a:noFill/>
-        </p:spPr>
-        <p:txBody>
-          <a:bodyPr wrap="square" lIns="0" rIns="0" tIns="0" bIns="0">
-            <a:normAutofit/>
-          </a:bodyPr>
-          <a:lstStyle/>
-          <a:p>
-            <a:pPr algn="l"/>
-            <a:r>
-              <a:rPr sz="1800" b="1">
-                <a:solidFill>
-                  <a:srgbClr val="FFFFFF"/>
-                </a:solidFill>
-                <a:latin typeface="Aptos"/>
-              </a:rPr>
-              <a:t>Educação complementar</a:t>
+            <a:off x="978408" y="2441448"/>
+            <a:ext cx="4626864" cy="256032"/>
+          </a:xfrm>
+          <a:prstGeom prst="rect">
+            <a:avLst/>
+          </a:prstGeom>
+          <a:noFill/>
+        </p:spPr>
+        <p:txBody>
+          <a:bodyPr wrap="square" lIns="0" rIns="0" tIns="0" bIns="0">
+            <a:normAutofit/>
+          </a:bodyPr>
+          <a:lstStyle/>
+          <a:p>
+            <a:pPr algn="l"/>
+            <a:r>
+              <a:rPr sz="1600" b="1">
+                <a:solidFill>
+                  <a:srgbClr val="1E2761"/>
+                </a:solidFill>
+                <a:latin typeface="Aptos"/>
+              </a:rPr>
+              <a:t>Saúde 1</a:t>
             </a:r>
           </a:p>
         </p:txBody>
@@ -4975,65 +5561,149 @@
         </p:nvSpPr>
         <p:spPr>
           <a:xfrm>
-            <a:off x="1005840" y="3063240"/>
-            <a:ext cx="2468880" cy="2011680"/>
-          </a:xfrm>
-          <a:prstGeom prst="rect">
-            <a:avLst/>
-          </a:prstGeom>
-          <a:noFill/>
-        </p:spPr>
-        <p:txBody>
-          <a:bodyPr wrap="square" lIns="0" rIns="0" tIns="0" bIns="0">
-            <a:normAutofit/>
-          </a:bodyPr>
-          <a:lstStyle/>
-          <a:p>
-            <a:pPr algn="l"/>
-            <a:r>
-              <a:rPr sz="1600" b="0">
-                <a:solidFill>
-                  <a:srgbClr val="FFFFFF"/>
-                </a:solidFill>
-                <a:latin typeface="Aptos"/>
-              </a:rPr>
-              <a:t>Centro Educacional Maria Auxiliadora</a:t>
-            </a:r>
-          </a:p>
-          <a:p>
-            <a:pPr algn="l"/>
-            <a:r>
-              <a:rPr sz="1600" b="0">
-                <a:solidFill>
-                  <a:srgbClr val="FFFFFF"/>
-                </a:solidFill>
-                <a:latin typeface="Aptos"/>
-              </a:rPr>
-              <a:t>UNYLEYA</a:t>
-            </a:r>
-          </a:p>
-          <a:p>
-            <a:pPr algn="l"/>
-            <a:r>
-              <a:rPr sz="1600" b="0">
-                <a:solidFill>
-                  <a:srgbClr val="FFFFFF"/>
-                </a:solidFill>
-                <a:latin typeface="Aptos"/>
-              </a:rPr>
-              <a:t>Instituto Formação para a Educação</a:t>
-            </a:r>
-          </a:p>
-          <a:p>
-            <a:pPr algn="l"/>
-            <a:r>
-              <a:rPr sz="1600" b="0">
-                <a:solidFill>
-                  <a:srgbClr val="FFFFFF"/>
-                </a:solidFill>
-                <a:latin typeface="Aptos"/>
-              </a:rPr>
-              <a:t>3W Educacional Editora e Cursos</a:t>
+            <a:off x="978408" y="2807208"/>
+            <a:ext cx="4626864" cy="3209543"/>
+          </a:xfrm>
+          <a:prstGeom prst="rect">
+            <a:avLst/>
+          </a:prstGeom>
+          <a:noFill/>
+        </p:spPr>
+        <p:txBody>
+          <a:bodyPr wrap="square" lIns="0" rIns="0" tIns="0" bIns="0">
+            <a:normAutofit/>
+          </a:bodyPr>
+          <a:lstStyle/>
+          <a:p>
+            <a:pPr algn="l"/>
+            <a:r>
+              <a:rPr sz="1300" b="0">
+                <a:solidFill>
+                  <a:srgbClr val="1A1A1A"/>
+                </a:solidFill>
+                <a:latin typeface="Aptos"/>
+              </a:rPr>
+              <a:t>Aquafisio Hidroterapia Esportiva</a:t>
+            </a:r>
+          </a:p>
+          <a:p>
+            <a:pPr algn="l"/>
+            <a:r>
+              <a:rPr sz="1300" b="0">
+                <a:solidFill>
+                  <a:srgbClr val="1A1A1A"/>
+                </a:solidFill>
+                <a:latin typeface="Aptos"/>
+              </a:rPr>
+              <a:t>Bonvena Medicina Reprodutiva</a:t>
+            </a:r>
+          </a:p>
+          <a:p>
+            <a:pPr algn="l"/>
+            <a:r>
+              <a:rPr sz="1300" b="0">
+                <a:solidFill>
+                  <a:srgbClr val="1A1A1A"/>
+                </a:solidFill>
+                <a:latin typeface="Aptos"/>
+              </a:rPr>
+              <a:t>CBV</a:t>
+            </a:r>
+          </a:p>
+          <a:p>
+            <a:pPr algn="l"/>
+            <a:r>
+              <a:rPr sz="1300" b="0">
+                <a:solidFill>
+                  <a:srgbClr val="1A1A1A"/>
+                </a:solidFill>
+                <a:latin typeface="Aptos"/>
+              </a:rPr>
+              <a:t>CDI Centro Diagnóstico por Imagem</a:t>
+            </a:r>
+          </a:p>
+          <a:p>
+            <a:pPr algn="l"/>
+            <a:r>
+              <a:rPr sz="1300" b="0">
+                <a:solidFill>
+                  <a:srgbClr val="1A1A1A"/>
+                </a:solidFill>
+                <a:latin typeface="Aptos"/>
+              </a:rPr>
+              <a:t>Centro de Medicina Nuclear da Guanabara</a:t>
+            </a:r>
+          </a:p>
+          <a:p>
+            <a:pPr algn="l"/>
+            <a:r>
+              <a:rPr sz="1300" b="0">
+                <a:solidFill>
+                  <a:srgbClr val="1A1A1A"/>
+                </a:solidFill>
+                <a:latin typeface="Aptos"/>
+              </a:rPr>
+              <a:t>CIORB</a:t>
+            </a:r>
+          </a:p>
+          <a:p>
+            <a:pPr algn="l"/>
+            <a:r>
+              <a:rPr sz="1300" b="0">
+                <a:solidFill>
+                  <a:srgbClr val="1A1A1A"/>
+                </a:solidFill>
+                <a:latin typeface="Aptos"/>
+              </a:rPr>
+              <a:t>Clínica Plenus Psicologia e Saúde Integrada</a:t>
+            </a:r>
+          </a:p>
+          <a:p>
+            <a:pPr algn="l"/>
+            <a:r>
+              <a:rPr sz="1300" b="0">
+                <a:solidFill>
+                  <a:srgbClr val="1A1A1A"/>
+                </a:solidFill>
+                <a:latin typeface="Aptos"/>
+              </a:rPr>
+              <a:t>Dermatologic</a:t>
+            </a:r>
+          </a:p>
+          <a:p>
+            <a:pPr algn="l"/>
+            <a:r>
+              <a:rPr sz="1300" b="0">
+                <a:solidFill>
+                  <a:srgbClr val="1A1A1A"/>
+                </a:solidFill>
+                <a:latin typeface="Aptos"/>
+              </a:rPr>
+              <a:t>EBM-Odonto</a:t>
+            </a:r>
+          </a:p>
+          <a:p>
+            <a:pPr algn="l"/>
+            <a:r>
+              <a:rPr sz="1300" b="0">
+                <a:solidFill>
+                  <a:srgbClr val="1A1A1A"/>
+                </a:solidFill>
+                <a:latin typeface="Aptos"/>
+              </a:rPr>
+              <a:t>Endogastrus</a:t>
+            </a:r>
+          </a:p>
+          <a:p>
+            <a:pPr algn="l"/>
+            <a:r>
+              <a:rPr sz="1300" b="0">
+                <a:solidFill>
+                  <a:srgbClr val="1A1A1A"/>
+                </a:solidFill>
+                <a:latin typeface="Aptos"/>
+              </a:rPr>
+              <a:t>Home Hospital Ortopédico e Medicina Especializada</a:t>
             </a:r>
           </a:p>
         </p:txBody>
@@ -5046,18 +5716,18 @@
         </p:nvSpPr>
         <p:spPr>
           <a:xfrm>
-            <a:off x="4160520" y="2331720"/>
-            <a:ext cx="3474720" cy="3566160"/>
+            <a:off x="6080760" y="2240280"/>
+            <a:ext cx="5303520" cy="3977639"/>
           </a:xfrm>
           <a:prstGeom prst="roundRect">
             <a:avLst/>
           </a:prstGeom>
           <a:solidFill>
-            <a:srgbClr val="FFFFFF"/>
+            <a:srgbClr val="F5F8FC"/>
           </a:solidFill>
           <a:ln>
             <a:solidFill>
-              <a:srgbClr val="FFFFFF"/>
+              <a:srgbClr val="F5F8FC"/>
             </a:solidFill>
           </a:ln>
         </p:spPr>
@@ -5085,46 +5755,36 @@
       </p:sp>
       <p:sp>
         <p:nvSpPr>
-          <p:cNvPr id="9" name="Rounded Rectangle 8"/>
-          <p:cNvSpPr/>
-          <p:nvPr/>
-        </p:nvSpPr>
-        <p:spPr>
-          <a:xfrm>
-            <a:off x="7818120" y="2331720"/>
-            <a:ext cx="3474720" cy="3566160"/>
-          </a:xfrm>
-          <a:prstGeom prst="roundRect">
-            <a:avLst/>
-          </a:prstGeom>
-          <a:solidFill>
-            <a:srgbClr val="FFFFFF"/>
-          </a:solidFill>
-          <a:ln>
-            <a:solidFill>
-              <a:srgbClr val="FFFFFF"/>
-            </a:solidFill>
-          </a:ln>
-        </p:spPr>
-        <p:style>
-          <a:lnRef idx="1">
-            <a:schemeClr val="accent1"/>
-          </a:lnRef>
-          <a:fillRef idx="3">
-            <a:schemeClr val="accent1"/>
-          </a:fillRef>
-          <a:effectRef idx="2">
-            <a:schemeClr val="accent1"/>
-          </a:effectRef>
-          <a:fontRef idx="minor">
-            <a:schemeClr val="lt1"/>
-          </a:fontRef>
-        </p:style>
-        <p:txBody>
-          <a:bodyPr rtlCol="0" anchor="ctr"/>
-          <a:lstStyle/>
-          <a:p>
-            <a:pPr algn="ctr"/>
+          <p:cNvPr id="9" name="TextBox 8"/>
+          <p:cNvSpPr txBox="1"/>
+          <p:nvPr/>
+        </p:nvSpPr>
+        <p:spPr>
+          <a:xfrm>
+            <a:off x="6281928" y="2441448"/>
+            <a:ext cx="4901184" cy="256032"/>
+          </a:xfrm>
+          <a:prstGeom prst="rect">
+            <a:avLst/>
+          </a:prstGeom>
+          <a:noFill/>
+        </p:spPr>
+        <p:txBody>
+          <a:bodyPr wrap="square" lIns="0" rIns="0" tIns="0" bIns="0">
+            <a:normAutofit/>
+          </a:bodyPr>
+          <a:lstStyle/>
+          <a:p>
+            <a:pPr algn="l"/>
+            <a:r>
+              <a:rPr sz="1600" b="1">
+                <a:solidFill>
+                  <a:srgbClr val="1E2761"/>
+                </a:solidFill>
+                <a:latin typeface="Aptos"/>
+              </a:rPr>
+              <a:t>Saúde 2</a:t>
+            </a:r>
           </a:p>
         </p:txBody>
       </p:sp>
@@ -5136,161 +5796,161 @@
         </p:nvSpPr>
         <p:spPr>
           <a:xfrm>
-            <a:off x="4389120" y="2651760"/>
-            <a:ext cx="2834640" cy="2834640"/>
-          </a:xfrm>
-          <a:prstGeom prst="rect">
-            <a:avLst/>
-          </a:prstGeom>
-          <a:noFill/>
-        </p:spPr>
-        <p:txBody>
-          <a:bodyPr wrap="square" lIns="0" rIns="0" tIns="0" bIns="0">
-            <a:normAutofit/>
-          </a:bodyPr>
-          <a:lstStyle/>
-          <a:p>
-            <a:pPr algn="l"/>
-            <a:r>
-              <a:rPr sz="1400" b="0">
+            <a:off x="6281928" y="2807208"/>
+            <a:ext cx="4901184" cy="3209543"/>
+          </a:xfrm>
+          <a:prstGeom prst="rect">
+            <a:avLst/>
+          </a:prstGeom>
+          <a:noFill/>
+        </p:spPr>
+        <p:txBody>
+          <a:bodyPr wrap="square" lIns="0" rIns="0" tIns="0" bIns="0">
+            <a:normAutofit/>
+          </a:bodyPr>
+          <a:lstStyle/>
+          <a:p>
+            <a:pPr algn="l"/>
+            <a:r>
+              <a:rPr sz="1300" b="0">
                 <a:solidFill>
                   <a:srgbClr val="1A1A1A"/>
                 </a:solidFill>
                 <a:latin typeface="Aptos"/>
               </a:rPr>
-              <a:t>Aquafisio Hidroterapia Esportiva</a:t>
-            </a:r>
-          </a:p>
-          <a:p>
-            <a:pPr algn="l"/>
-            <a:r>
-              <a:rPr sz="1400" b="0">
+              <a:t>Implantocard</a:t>
+            </a:r>
+          </a:p>
+          <a:p>
+            <a:pPr algn="l"/>
+            <a:r>
+              <a:rPr sz="1300" b="0">
                 <a:solidFill>
                   <a:srgbClr val="1A1A1A"/>
                 </a:solidFill>
                 <a:latin typeface="Aptos"/>
               </a:rPr>
-              <a:t>Bonvena Medicina Reprodutiva</a:t>
-            </a:r>
-          </a:p>
-          <a:p>
-            <a:pPr algn="l"/>
-            <a:r>
-              <a:rPr sz="1400" b="0">
+              <a:t>Juliana Cristina Paim Psicóloga Clínica e Neuropsicóloga</a:t>
+            </a:r>
+          </a:p>
+          <a:p>
+            <a:pPr algn="l"/>
+            <a:r>
+              <a:rPr sz="1300" b="0">
                 <a:solidFill>
                   <a:srgbClr val="1A1A1A"/>
                 </a:solidFill>
                 <a:latin typeface="Aptos"/>
               </a:rPr>
-              <a:t>CBV</a:t>
-            </a:r>
-          </a:p>
-          <a:p>
-            <a:pPr algn="l"/>
-            <a:r>
-              <a:rPr sz="1400" b="0">
+              <a:t>Laboratório Citoprev</a:t>
+            </a:r>
+          </a:p>
+          <a:p>
+            <a:pPr algn="l"/>
+            <a:r>
+              <a:rPr sz="1300" b="0">
                 <a:solidFill>
                   <a:srgbClr val="1A1A1A"/>
                 </a:solidFill>
                 <a:latin typeface="Aptos"/>
               </a:rPr>
-              <a:t>CDI Centro Diagnóstico por Imagem</a:t>
-            </a:r>
-          </a:p>
-          <a:p>
-            <a:pPr algn="l"/>
-            <a:r>
-              <a:rPr sz="1400" b="0">
+              <a:t>Mei Li Acupuntura</a:t>
+            </a:r>
+          </a:p>
+          <a:p>
+            <a:pPr algn="l"/>
+            <a:r>
+              <a:rPr sz="1300" b="0">
                 <a:solidFill>
                   <a:srgbClr val="1A1A1A"/>
                 </a:solidFill>
                 <a:latin typeface="Aptos"/>
               </a:rPr>
-              <a:t>Centro de Medicina Nuclear da Guanabara</a:t>
-            </a:r>
-          </a:p>
-          <a:p>
-            <a:pPr algn="l"/>
-            <a:r>
-              <a:rPr sz="1400" b="0">
+              <a:t>Oculare Oftalmologia</a:t>
+            </a:r>
+          </a:p>
+          <a:p>
+            <a:pPr algn="l"/>
+            <a:r>
+              <a:rPr sz="1300" b="0">
                 <a:solidFill>
                   <a:srgbClr val="1A1A1A"/>
                 </a:solidFill>
                 <a:latin typeface="Aptos"/>
               </a:rPr>
-              <a:t>CIORB</a:t>
-            </a:r>
-          </a:p>
-          <a:p>
-            <a:pPr algn="l"/>
-            <a:r>
-              <a:rPr sz="1400" b="0">
+              <a:t>Odontobrasília</a:t>
+            </a:r>
+          </a:p>
+          <a:p>
+            <a:pPr algn="l"/>
+            <a:r>
+              <a:rPr sz="1300" b="0">
                 <a:solidFill>
                   <a:srgbClr val="1A1A1A"/>
                 </a:solidFill>
                 <a:latin typeface="Aptos"/>
               </a:rPr>
-              <a:t>Clínica Plenus Psicologia e Saúde Integrada</a:t>
-            </a:r>
-          </a:p>
-          <a:p>
-            <a:pPr algn="l"/>
-            <a:r>
-              <a:rPr sz="1400" b="0">
+              <a:t>Odontoempresa</a:t>
+            </a:r>
+          </a:p>
+          <a:p>
+            <a:pPr algn="l"/>
+            <a:r>
+              <a:rPr sz="1300" b="0">
                 <a:solidFill>
                   <a:srgbClr val="1A1A1A"/>
                 </a:solidFill>
                 <a:latin typeface="Aptos"/>
               </a:rPr>
-              <a:t>Dermatologic</a:t>
-            </a:r>
-          </a:p>
-          <a:p>
-            <a:pPr algn="l"/>
-            <a:r>
-              <a:rPr sz="1400" b="0">
+              <a:t>Ressonance</a:t>
+            </a:r>
+          </a:p>
+          <a:p>
+            <a:pPr algn="l"/>
+            <a:r>
+              <a:rPr sz="1300" b="0">
                 <a:solidFill>
                   <a:srgbClr val="1A1A1A"/>
                 </a:solidFill>
                 <a:latin typeface="Aptos"/>
               </a:rPr>
-              <a:t>EBM-Odonto</a:t>
-            </a:r>
-          </a:p>
-          <a:p>
-            <a:pPr algn="l"/>
-            <a:r>
-              <a:rPr sz="1400" b="0">
+              <a:t>Rita Trindade</a:t>
+            </a:r>
+          </a:p>
+          <a:p>
+            <a:pPr algn="l"/>
+            <a:r>
+              <a:rPr sz="1300" b="0">
                 <a:solidFill>
                   <a:srgbClr val="1A1A1A"/>
                 </a:solidFill>
                 <a:latin typeface="Aptos"/>
               </a:rPr>
-              <a:t>Endogastrus</a:t>
-            </a:r>
-          </a:p>
-          <a:p>
-            <a:pPr algn="l"/>
-            <a:r>
-              <a:rPr sz="1400" b="0">
+              <a:t>RM Clínica Médica e Estética</a:t>
+            </a:r>
+          </a:p>
+          <a:p>
+            <a:pPr algn="l"/>
+            <a:r>
+              <a:rPr sz="1300" b="0">
                 <a:solidFill>
                   <a:srgbClr val="1A1A1A"/>
                 </a:solidFill>
                 <a:latin typeface="Aptos"/>
               </a:rPr>
-              <a:t>Home Hospital Ortopédico e Medicina Especializada</a:t>
-            </a:r>
-          </a:p>
-          <a:p>
-            <a:pPr algn="l"/>
-            <a:r>
-              <a:rPr sz="1400" b="0">
+              <a:t>Sabin</a:t>
+            </a:r>
+          </a:p>
+          <a:p>
+            <a:pPr algn="l"/>
+            <a:r>
+              <a:rPr sz="1300" b="0">
                 <a:solidFill>
                   <a:srgbClr val="1A1A1A"/>
                 </a:solidFill>
                 <a:latin typeface="Aptos"/>
               </a:rPr>
-              <a:t>Implantocard</a:t>
+              <a:t>Souli Psicologia e Psicopedagogia</a:t>
             </a:r>
           </a:p>
         </p:txBody>
@@ -5303,163 +5963,8 @@
         </p:nvSpPr>
         <p:spPr>
           <a:xfrm>
-            <a:off x="8046720" y="2651760"/>
-            <a:ext cx="2834640" cy="2834640"/>
-          </a:xfrm>
-          <a:prstGeom prst="rect">
-            <a:avLst/>
-          </a:prstGeom>
-          <a:noFill/>
-        </p:spPr>
-        <p:txBody>
-          <a:bodyPr wrap="square" lIns="0" rIns="0" tIns="0" bIns="0">
-            <a:normAutofit/>
-          </a:bodyPr>
-          <a:lstStyle/>
-          <a:p>
-            <a:pPr algn="l"/>
-            <a:r>
-              <a:rPr sz="1400" b="0">
-                <a:solidFill>
-                  <a:srgbClr val="1A1A1A"/>
-                </a:solidFill>
-                <a:latin typeface="Aptos"/>
-              </a:rPr>
-              <a:t>Juliana Cristina Paim Psicóloga Clínica e Neuropsicóloga</a:t>
-            </a:r>
-          </a:p>
-          <a:p>
-            <a:pPr algn="l"/>
-            <a:r>
-              <a:rPr sz="1400" b="0">
-                <a:solidFill>
-                  <a:srgbClr val="1A1A1A"/>
-                </a:solidFill>
-                <a:latin typeface="Aptos"/>
-              </a:rPr>
-              <a:t>Laboratório Citoprev</a:t>
-            </a:r>
-          </a:p>
-          <a:p>
-            <a:pPr algn="l"/>
-            <a:r>
-              <a:rPr sz="1400" b="0">
-                <a:solidFill>
-                  <a:srgbClr val="1A1A1A"/>
-                </a:solidFill>
-                <a:latin typeface="Aptos"/>
-              </a:rPr>
-              <a:t>Mei Li Acupuntura</a:t>
-            </a:r>
-          </a:p>
-          <a:p>
-            <a:pPr algn="l"/>
-            <a:r>
-              <a:rPr sz="1400" b="0">
-                <a:solidFill>
-                  <a:srgbClr val="1A1A1A"/>
-                </a:solidFill>
-                <a:latin typeface="Aptos"/>
-              </a:rPr>
-              <a:t>Oculare Oftalmologia</a:t>
-            </a:r>
-          </a:p>
-          <a:p>
-            <a:pPr algn="l"/>
-            <a:r>
-              <a:rPr sz="1400" b="0">
-                <a:solidFill>
-                  <a:srgbClr val="1A1A1A"/>
-                </a:solidFill>
-                <a:latin typeface="Aptos"/>
-              </a:rPr>
-              <a:t>Odontobrasília</a:t>
-            </a:r>
-          </a:p>
-          <a:p>
-            <a:pPr algn="l"/>
-            <a:r>
-              <a:rPr sz="1400" b="0">
-                <a:solidFill>
-                  <a:srgbClr val="1A1A1A"/>
-                </a:solidFill>
-                <a:latin typeface="Aptos"/>
-              </a:rPr>
-              <a:t>Odontoempresa</a:t>
-            </a:r>
-          </a:p>
-          <a:p>
-            <a:pPr algn="l"/>
-            <a:r>
-              <a:rPr sz="1400" b="0">
-                <a:solidFill>
-                  <a:srgbClr val="1A1A1A"/>
-                </a:solidFill>
-                <a:latin typeface="Aptos"/>
-              </a:rPr>
-              <a:t>Ressonance</a:t>
-            </a:r>
-          </a:p>
-          <a:p>
-            <a:pPr algn="l"/>
-            <a:r>
-              <a:rPr sz="1400" b="0">
-                <a:solidFill>
-                  <a:srgbClr val="1A1A1A"/>
-                </a:solidFill>
-                <a:latin typeface="Aptos"/>
-              </a:rPr>
-              <a:t>Rita Trindade</a:t>
-            </a:r>
-          </a:p>
-          <a:p>
-            <a:pPr algn="l"/>
-            <a:r>
-              <a:rPr sz="1400" b="0">
-                <a:solidFill>
-                  <a:srgbClr val="1A1A1A"/>
-                </a:solidFill>
-                <a:latin typeface="Aptos"/>
-              </a:rPr>
-              <a:t>RM Clínica Médica e Estética</a:t>
-            </a:r>
-          </a:p>
-          <a:p>
-            <a:pPr algn="l"/>
-            <a:r>
-              <a:rPr sz="1400" b="0">
-                <a:solidFill>
-                  <a:srgbClr val="1A1A1A"/>
-                </a:solidFill>
-                <a:latin typeface="Aptos"/>
-              </a:rPr>
-              <a:t>Sabin</a:t>
-            </a:r>
-          </a:p>
-          <a:p>
-            <a:pPr algn="l"/>
-            <a:r>
-              <a:rPr sz="1400" b="0">
-                <a:solidFill>
-                  <a:srgbClr val="1A1A1A"/>
-                </a:solidFill>
-                <a:latin typeface="Aptos"/>
-              </a:rPr>
-              <a:t>Souli Psicologia e Psicopedagogia</a:t>
-            </a:r>
-          </a:p>
-        </p:txBody>
-      </p:sp>
-      <p:sp>
-        <p:nvSpPr>
-          <p:cNvPr id="12" name="TextBox 11"/>
-          <p:cNvSpPr txBox="1"/>
-          <p:nvPr/>
-        </p:nvSpPr>
-        <p:spPr>
-          <a:xfrm>
-            <a:off x="10881360" y="6400800"/>
-            <a:ext cx="640080" cy="228600"/>
+            <a:off x="10808208" y="6144768"/>
+            <a:ext cx="713232" cy="228600"/>
           </a:xfrm>
           <a:prstGeom prst="rect">
             <a:avLst/>
@@ -5480,7 +5985,7 @@
                 </a:solidFill>
                 <a:latin typeface="Aptos"/>
               </a:rPr>
-              <a:t>12 / 14</a:t>
+              <a:t>13 / 16</a:t>
             </a:r>
           </a:p>
         </p:txBody>
@@ -5493,7 +5998,7 @@
 </p:sld>
 </file>
 
-<file path=ppt/slides/slide13.xml><?xml version="1.0" encoding="utf-8"?>
+<file path=ppt/slides/slide14.xml><?xml version="1.0" encoding="utf-8"?>
 <p:sld xmlns:a="http://schemas.openxmlformats.org/drawingml/2006/main" xmlns:p="http://schemas.openxmlformats.org/presentationml/2006/main" xmlns:r="http://schemas.openxmlformats.org/officeDocument/2006/relationships">
   <p:cSld>
     <p:bg>
@@ -5576,21 +6081,56 @@
                 </a:solidFill>
                 <a:latin typeface="Aptos Display"/>
               </a:rPr>
-              <a:t>Convênios de saúde complementar e lazer e bem-estar</a:t>
-            </a:r>
-          </a:p>
-        </p:txBody>
-      </p:sp>
-      <p:sp>
-        <p:nvSpPr>
-          <p:cNvPr id="4" name="Rounded Rectangle 3"/>
+              <a:t>Convênios de saúde complementar</a:t>
+            </a:r>
+          </a:p>
+        </p:txBody>
+      </p:sp>
+      <p:sp>
+        <p:nvSpPr>
+          <p:cNvPr id="4" name="TextBox 3"/>
+          <p:cNvSpPr txBox="1"/>
+          <p:nvPr/>
+        </p:nvSpPr>
+        <p:spPr>
+          <a:xfrm>
+            <a:off x="731520" y="1600200"/>
+            <a:ext cx="6949440" cy="411480"/>
+          </a:xfrm>
+          <a:prstGeom prst="rect">
+            <a:avLst/>
+          </a:prstGeom>
+          <a:noFill/>
+        </p:spPr>
+        <p:txBody>
+          <a:bodyPr wrap="square" lIns="0" rIns="0" tIns="0" bIns="0">
+            <a:normAutofit/>
+          </a:bodyPr>
+          <a:lstStyle/>
+          <a:p>
+            <a:pPr algn="l"/>
+            <a:r>
+              <a:rPr sz="1700" b="0">
+                <a:solidFill>
+                  <a:srgbClr val="5C6674"/>
+                </a:solidFill>
+                <a:latin typeface="Aptos"/>
+              </a:rPr>
+              <a:t>Parceiros adicionais citados em subpastas e documentação complementar do acervo.</a:t>
+            </a:r>
+          </a:p>
+        </p:txBody>
+      </p:sp>
+      <p:sp>
+        <p:nvSpPr>
+          <p:cNvPr id="5" name="Rounded Rectangle 4"/>
           <p:cNvSpPr/>
           <p:nvPr/>
         </p:nvSpPr>
         <p:spPr>
           <a:xfrm>
-            <a:off x="777240" y="1737360"/>
-            <a:ext cx="2926080" cy="4206240"/>
+            <a:off x="822960" y="2331720"/>
+            <a:ext cx="3657600" cy="2560320"/>
           </a:xfrm>
           <a:prstGeom prst="roundRect">
             <a:avLst/>
@@ -5628,64 +6168,64 @@
       </p:sp>
       <p:sp>
         <p:nvSpPr>
-          <p:cNvPr id="5" name="TextBox 4"/>
-          <p:cNvSpPr txBox="1"/>
-          <p:nvPr/>
-        </p:nvSpPr>
-        <p:spPr>
-          <a:xfrm>
-            <a:off x="1051560" y="2057400"/>
-            <a:ext cx="2286000" cy="274320"/>
-          </a:xfrm>
-          <a:prstGeom prst="rect">
-            <a:avLst/>
-          </a:prstGeom>
-          <a:noFill/>
-        </p:spPr>
-        <p:txBody>
-          <a:bodyPr wrap="square" lIns="0" rIns="0" tIns="0" bIns="0">
-            <a:normAutofit/>
-          </a:bodyPr>
-          <a:lstStyle/>
-          <a:p>
-            <a:pPr algn="l"/>
-            <a:r>
-              <a:rPr sz="1800" b="1">
+          <p:cNvPr id="6" name="TextBox 5"/>
+          <p:cNvSpPr txBox="1"/>
+          <p:nvPr/>
+        </p:nvSpPr>
+        <p:spPr>
+          <a:xfrm>
+            <a:off x="1024128" y="2532888"/>
+            <a:ext cx="3255264" cy="256032"/>
+          </a:xfrm>
+          <a:prstGeom prst="rect">
+            <a:avLst/>
+          </a:prstGeom>
+          <a:noFill/>
+        </p:spPr>
+        <p:txBody>
+          <a:bodyPr wrap="square" lIns="0" rIns="0" tIns="0" bIns="0">
+            <a:normAutofit/>
+          </a:bodyPr>
+          <a:lstStyle/>
+          <a:p>
+            <a:pPr algn="l"/>
+            <a:r>
+              <a:rPr sz="1600" b="1">
                 <a:solidFill>
                   <a:srgbClr val="FFFFFF"/>
                 </a:solidFill>
                 <a:latin typeface="Aptos"/>
               </a:rPr>
-              <a:t>Saúde complementar</a:t>
-            </a:r>
-          </a:p>
-        </p:txBody>
-      </p:sp>
-      <p:sp>
-        <p:nvSpPr>
-          <p:cNvPr id="6" name="TextBox 5"/>
-          <p:cNvSpPr txBox="1"/>
-          <p:nvPr/>
-        </p:nvSpPr>
-        <p:spPr>
-          <a:xfrm>
-            <a:off x="1051560" y="2560320"/>
-            <a:ext cx="2148840" cy="1828800"/>
-          </a:xfrm>
-          <a:prstGeom prst="rect">
-            <a:avLst/>
-          </a:prstGeom>
-          <a:noFill/>
-        </p:spPr>
-        <p:txBody>
-          <a:bodyPr wrap="square" lIns="0" rIns="0" tIns="0" bIns="0">
-            <a:normAutofit/>
-          </a:bodyPr>
-          <a:lstStyle/>
-          <a:p>
-            <a:pPr algn="l"/>
-            <a:r>
-              <a:rPr sz="1600" b="0">
+              <a:t>Complementares</a:t>
+            </a:r>
+          </a:p>
+        </p:txBody>
+      </p:sp>
+      <p:sp>
+        <p:nvSpPr>
+          <p:cNvPr id="7" name="TextBox 6"/>
+          <p:cNvSpPr txBox="1"/>
+          <p:nvPr/>
+        </p:nvSpPr>
+        <p:spPr>
+          <a:xfrm>
+            <a:off x="1024128" y="2898648"/>
+            <a:ext cx="3255264" cy="1792224"/>
+          </a:xfrm>
+          <a:prstGeom prst="rect">
+            <a:avLst/>
+          </a:prstGeom>
+          <a:noFill/>
+        </p:spPr>
+        <p:txBody>
+          <a:bodyPr wrap="square" lIns="0" rIns="0" tIns="0" bIns="0">
+            <a:normAutofit/>
+          </a:bodyPr>
+          <a:lstStyle/>
+          <a:p>
+            <a:pPr algn="l"/>
+            <a:r>
+              <a:rPr sz="1300" b="0">
                 <a:solidFill>
                   <a:srgbClr val="FFFFFF"/>
                 </a:solidFill>
@@ -5697,7 +6237,7 @@
           <a:p>
             <a:pPr algn="l"/>
             <a:r>
-              <a:rPr sz="1600" b="0">
+              <a:rPr sz="1300" b="0">
                 <a:solidFill>
                   <a:srgbClr val="FFFFFF"/>
                 </a:solidFill>
@@ -5709,7 +6249,7 @@
           <a:p>
             <a:pPr algn="l"/>
             <a:r>
-              <a:rPr sz="1600" b="0">
+              <a:rPr sz="1300" b="0">
                 <a:solidFill>
                   <a:srgbClr val="FFFFFF"/>
                 </a:solidFill>
@@ -5721,7 +6261,7 @@
           <a:p>
             <a:pPr algn="l"/>
             <a:r>
-              <a:rPr sz="1600" b="0">
+              <a:rPr sz="1300" b="0">
                 <a:solidFill>
                   <a:srgbClr val="FFFFFF"/>
                 </a:solidFill>
@@ -5733,7 +6273,7 @@
           <a:p>
             <a:pPr algn="l"/>
             <a:r>
-              <a:rPr sz="1600" b="0">
+              <a:rPr sz="1300" b="0">
                 <a:solidFill>
                   <a:srgbClr val="FFFFFF"/>
                 </a:solidFill>
@@ -5746,14 +6286,330 @@
       </p:sp>
       <p:sp>
         <p:nvSpPr>
-          <p:cNvPr id="7" name="Rounded Rectangle 6"/>
+          <p:cNvPr id="8" name="Rounded Rectangle 7"/>
           <p:cNvSpPr/>
           <p:nvPr/>
         </p:nvSpPr>
         <p:spPr>
           <a:xfrm>
-            <a:off x="3977639" y="1737360"/>
-            <a:ext cx="3474720" cy="4206240"/>
+            <a:off x="4892040" y="2331720"/>
+            <a:ext cx="6355080" cy="2560320"/>
+          </a:xfrm>
+          <a:prstGeom prst="roundRect">
+            <a:avLst/>
+          </a:prstGeom>
+          <a:solidFill>
+            <a:srgbClr val="065A82"/>
+          </a:solidFill>
+          <a:ln>
+            <a:solidFill>
+              <a:srgbClr val="065A82"/>
+            </a:solidFill>
+          </a:ln>
+        </p:spPr>
+        <p:style>
+          <a:lnRef idx="1">
+            <a:schemeClr val="accent1"/>
+          </a:lnRef>
+          <a:fillRef idx="3">
+            <a:schemeClr val="accent1"/>
+          </a:fillRef>
+          <a:effectRef idx="2">
+            <a:schemeClr val="accent1"/>
+          </a:effectRef>
+          <a:fontRef idx="minor">
+            <a:schemeClr val="lt1"/>
+          </a:fontRef>
+        </p:style>
+        <p:txBody>
+          <a:bodyPr rtlCol="0" anchor="ctr"/>
+          <a:lstStyle/>
+          <a:p>
+            <a:pPr algn="ctr"/>
+          </a:p>
+        </p:txBody>
+      </p:sp>
+      <p:sp>
+        <p:nvSpPr>
+          <p:cNvPr id="9" name="TextBox 8"/>
+          <p:cNvSpPr txBox="1"/>
+          <p:nvPr/>
+        </p:nvSpPr>
+        <p:spPr>
+          <a:xfrm>
+            <a:off x="5166360" y="2606040"/>
+            <a:ext cx="2286000" cy="228600"/>
+          </a:xfrm>
+          <a:prstGeom prst="rect">
+            <a:avLst/>
+          </a:prstGeom>
+          <a:noFill/>
+        </p:spPr>
+        <p:txBody>
+          <a:bodyPr wrap="square" lIns="0" rIns="0" tIns="0" bIns="0">
+            <a:normAutofit/>
+          </a:bodyPr>
+          <a:lstStyle/>
+          <a:p>
+            <a:pPr algn="l"/>
+            <a:r>
+              <a:rPr sz="1600" b="1">
+                <a:solidFill>
+                  <a:srgbClr val="FFFFFF"/>
+                </a:solidFill>
+                <a:latin typeface="Aptos"/>
+              </a:rPr>
+              <a:t>Leitura editorial</a:t>
+            </a:r>
+          </a:p>
+        </p:txBody>
+      </p:sp>
+      <p:sp>
+        <p:nvSpPr>
+          <p:cNvPr id="10" name="TextBox 9"/>
+          <p:cNvSpPr txBox="1"/>
+          <p:nvPr/>
+        </p:nvSpPr>
+        <p:spPr>
+          <a:xfrm>
+            <a:off x="5166360" y="2971800"/>
+            <a:ext cx="5669280" cy="1234440"/>
+          </a:xfrm>
+          <a:prstGeom prst="rect">
+            <a:avLst/>
+          </a:prstGeom>
+          <a:noFill/>
+        </p:spPr>
+        <p:txBody>
+          <a:bodyPr wrap="square" lIns="0" rIns="0" tIns="0" bIns="0">
+            <a:normAutofit/>
+          </a:bodyPr>
+          <a:lstStyle/>
+          <a:p>
+            <a:pPr algn="l"/>
+            <a:r>
+              <a:rPr sz="1900" b="1">
+                <a:solidFill>
+                  <a:srgbClr val="FFFFFF"/>
+                </a:solidFill>
+                <a:latin typeface="Aptos"/>
+              </a:rPr>
+              <a:t>A frente de saúde é a mais densa do acervo e cobre diagnósticos, clínicas, odontologia, psicologia, oftalmologia e serviços terapêuticos.</a:t>
+            </a:r>
+          </a:p>
+        </p:txBody>
+      </p:sp>
+      <p:sp>
+        <p:nvSpPr>
+          <p:cNvPr id="11" name="TextBox 10"/>
+          <p:cNvSpPr txBox="1"/>
+          <p:nvPr/>
+        </p:nvSpPr>
+        <p:spPr>
+          <a:xfrm>
+            <a:off x="5166360" y="4297680"/>
+            <a:ext cx="5394960" cy="411480"/>
+          </a:xfrm>
+          <a:prstGeom prst="rect">
+            <a:avLst/>
+          </a:prstGeom>
+          <a:noFill/>
+        </p:spPr>
+        <p:txBody>
+          <a:bodyPr wrap="square" lIns="0" rIns="0" tIns="0" bIns="0">
+            <a:normAutofit/>
+          </a:bodyPr>
+          <a:lstStyle/>
+          <a:p>
+            <a:pPr algn="l"/>
+            <a:r>
+              <a:rPr sz="1300" b="0">
+                <a:solidFill>
+                  <a:srgbClr val="CADCFC"/>
+                </a:solidFill>
+                <a:latin typeface="Aptos"/>
+              </a:rPr>
+              <a:t>Na apresentação ao vivo, vale citar poucos exemplos e usar este slide como apoio de consulta, não como leitura integral.</a:t>
+            </a:r>
+          </a:p>
+        </p:txBody>
+      </p:sp>
+      <p:sp>
+        <p:nvSpPr>
+          <p:cNvPr id="12" name="TextBox 11"/>
+          <p:cNvSpPr txBox="1"/>
+          <p:nvPr/>
+        </p:nvSpPr>
+        <p:spPr>
+          <a:xfrm>
+            <a:off x="10808208" y="6144768"/>
+            <a:ext cx="713232" cy="228600"/>
+          </a:xfrm>
+          <a:prstGeom prst="rect">
+            <a:avLst/>
+          </a:prstGeom>
+          <a:noFill/>
+        </p:spPr>
+        <p:txBody>
+          <a:bodyPr wrap="square" lIns="0" rIns="0" tIns="0" bIns="0">
+            <a:normAutofit/>
+          </a:bodyPr>
+          <a:lstStyle/>
+          <a:p>
+            <a:pPr algn="r"/>
+            <a:r>
+              <a:rPr sz="1000" b="0">
+                <a:solidFill>
+                  <a:srgbClr val="5C6674"/>
+                </a:solidFill>
+                <a:latin typeface="Aptos"/>
+              </a:rPr>
+              <a:t>14 / 16</a:t>
+            </a:r>
+          </a:p>
+        </p:txBody>
+      </p:sp>
+    </p:spTree>
+  </p:cSld>
+  <p:clrMapOvr>
+    <a:masterClrMapping/>
+  </p:clrMapOvr>
+</p:sld>
+</file>
+
+<file path=ppt/slides/slide15.xml><?xml version="1.0" encoding="utf-8"?>
+<p:sld xmlns:a="http://schemas.openxmlformats.org/drawingml/2006/main" xmlns:p="http://schemas.openxmlformats.org/presentationml/2006/main" xmlns:r="http://schemas.openxmlformats.org/officeDocument/2006/relationships">
+  <p:cSld>
+    <p:bg>
+      <p:bgPr>
+        <a:solidFill>
+          <a:srgbClr val="F5F8FC"/>
+        </a:solidFill>
+        <a:effectLst/>
+      </p:bgPr>
+    </p:bg>
+    <p:spTree>
+      <p:nvGrpSpPr>
+        <p:cNvPr id="1" name=""/>
+        <p:cNvGrpSpPr/>
+        <p:nvPr/>
+      </p:nvGrpSpPr>
+      <p:grpSpPr/>
+      <p:sp>
+        <p:nvSpPr>
+          <p:cNvPr id="2" name="TextBox 1"/>
+          <p:cNvSpPr txBox="1"/>
+          <p:nvPr/>
+        </p:nvSpPr>
+        <p:spPr>
+          <a:xfrm>
+            <a:off x="731520" y="411480"/>
+            <a:ext cx="3108960" cy="274320"/>
+          </a:xfrm>
+          <a:prstGeom prst="rect">
+            <a:avLst/>
+          </a:prstGeom>
+          <a:noFill/>
+        </p:spPr>
+        <p:txBody>
+          <a:bodyPr wrap="square" lIns="0" rIns="0" tIns="0" bIns="0">
+            <a:normAutofit/>
+          </a:bodyPr>
+          <a:lstStyle/>
+          <a:p>
+            <a:pPr algn="l"/>
+            <a:r>
+              <a:rPr sz="1200" b="1">
+                <a:solidFill>
+                  <a:srgbClr val="065A82"/>
+                </a:solidFill>
+                <a:latin typeface="Aptos"/>
+              </a:rPr>
+              <a:t>APÊNDICE</a:t>
+            </a:r>
+          </a:p>
+        </p:txBody>
+      </p:sp>
+      <p:sp>
+        <p:nvSpPr>
+          <p:cNvPr id="3" name="TextBox 2"/>
+          <p:cNvSpPr txBox="1"/>
+          <p:nvPr/>
+        </p:nvSpPr>
+        <p:spPr>
+          <a:xfrm>
+            <a:off x="731520" y="731520"/>
+            <a:ext cx="8046720" cy="960120"/>
+          </a:xfrm>
+          <a:prstGeom prst="rect">
+            <a:avLst/>
+          </a:prstGeom>
+          <a:noFill/>
+        </p:spPr>
+        <p:txBody>
+          <a:bodyPr wrap="square" lIns="0" rIns="0" tIns="0" bIns="0">
+            <a:normAutofit/>
+          </a:bodyPr>
+          <a:lstStyle/>
+          <a:p>
+            <a:pPr algn="l"/>
+            <a:r>
+              <a:rPr sz="2800" b="1">
+                <a:solidFill>
+                  <a:srgbClr val="1E2761"/>
+                </a:solidFill>
+                <a:latin typeface="Aptos Display"/>
+              </a:rPr>
+              <a:t>Convênios de lazer e bem-estar</a:t>
+            </a:r>
+          </a:p>
+        </p:txBody>
+      </p:sp>
+      <p:sp>
+        <p:nvSpPr>
+          <p:cNvPr id="4" name="TextBox 3"/>
+          <p:cNvSpPr txBox="1"/>
+          <p:nvPr/>
+        </p:nvSpPr>
+        <p:spPr>
+          <a:xfrm>
+            <a:off x="731520" y="1600200"/>
+            <a:ext cx="7589520" cy="411480"/>
+          </a:xfrm>
+          <a:prstGeom prst="rect">
+            <a:avLst/>
+          </a:prstGeom>
+          <a:noFill/>
+        </p:spPr>
+        <p:txBody>
+          <a:bodyPr wrap="square" lIns="0" rIns="0" tIns="0" bIns="0">
+            <a:normAutofit/>
+          </a:bodyPr>
+          <a:lstStyle/>
+          <a:p>
+            <a:pPr algn="l"/>
+            <a:r>
+              <a:rPr sz="1700" b="0">
+                <a:solidFill>
+                  <a:srgbClr val="5C6674"/>
+                </a:solidFill>
+                <a:latin typeface="Aptos"/>
+              </a:rPr>
+              <a:t>A categoria reúne atividades físicas, turismo, estética, hotelaria e serviços voltados à qualidade de vida.</a:t>
+            </a:r>
+          </a:p>
+        </p:txBody>
+      </p:sp>
+      <p:sp>
+        <p:nvSpPr>
+          <p:cNvPr id="5" name="Rounded Rectangle 4"/>
+          <p:cNvSpPr/>
+          <p:nvPr/>
+        </p:nvSpPr>
+        <p:spPr>
+          <a:xfrm>
+            <a:off x="777240" y="2240280"/>
+            <a:ext cx="5120640" cy="3977639"/>
           </a:xfrm>
           <a:prstGeom prst="roundRect">
             <a:avLst/>
@@ -5791,14 +6647,216 @@
       </p:sp>
       <p:sp>
         <p:nvSpPr>
+          <p:cNvPr id="6" name="TextBox 5"/>
+          <p:cNvSpPr txBox="1"/>
+          <p:nvPr/>
+        </p:nvSpPr>
+        <p:spPr>
+          <a:xfrm>
+            <a:off x="978408" y="2441448"/>
+            <a:ext cx="4718304" cy="256032"/>
+          </a:xfrm>
+          <a:prstGeom prst="rect">
+            <a:avLst/>
+          </a:prstGeom>
+          <a:noFill/>
+        </p:spPr>
+        <p:txBody>
+          <a:bodyPr wrap="square" lIns="0" rIns="0" tIns="0" bIns="0">
+            <a:normAutofit/>
+          </a:bodyPr>
+          <a:lstStyle/>
+          <a:p>
+            <a:pPr algn="l"/>
+            <a:r>
+              <a:rPr sz="1600" b="1">
+                <a:solidFill>
+                  <a:srgbClr val="1E2761"/>
+                </a:solidFill>
+                <a:latin typeface="Aptos"/>
+              </a:rPr>
+              <a:t>Lazer e bem-estar 1</a:t>
+            </a:r>
+          </a:p>
+        </p:txBody>
+      </p:sp>
+      <p:sp>
+        <p:nvSpPr>
+          <p:cNvPr id="7" name="TextBox 6"/>
+          <p:cNvSpPr txBox="1"/>
+          <p:nvPr/>
+        </p:nvSpPr>
+        <p:spPr>
+          <a:xfrm>
+            <a:off x="978408" y="2807208"/>
+            <a:ext cx="4718304" cy="3209543"/>
+          </a:xfrm>
+          <a:prstGeom prst="rect">
+            <a:avLst/>
+          </a:prstGeom>
+          <a:noFill/>
+        </p:spPr>
+        <p:txBody>
+          <a:bodyPr wrap="square" lIns="0" rIns="0" tIns="0" bIns="0">
+            <a:normAutofit/>
+          </a:bodyPr>
+          <a:lstStyle/>
+          <a:p>
+            <a:pPr algn="l"/>
+            <a:r>
+              <a:rPr sz="1300" b="0">
+                <a:solidFill>
+                  <a:srgbClr val="1A1A1A"/>
+                </a:solidFill>
+                <a:latin typeface="Aptos"/>
+              </a:rPr>
+              <a:t>Academia Club 22</a:t>
+            </a:r>
+          </a:p>
+          <a:p>
+            <a:pPr algn="l"/>
+            <a:r>
+              <a:rPr sz="1300" b="0">
+                <a:solidFill>
+                  <a:srgbClr val="1A1A1A"/>
+                </a:solidFill>
+                <a:latin typeface="Aptos"/>
+              </a:rPr>
+              <a:t>Academia Companhia Athletica</a:t>
+            </a:r>
+          </a:p>
+          <a:p>
+            <a:pPr algn="l"/>
+            <a:r>
+              <a:rPr sz="1300" b="0">
+                <a:solidFill>
+                  <a:srgbClr val="1A1A1A"/>
+                </a:solidFill>
+                <a:latin typeface="Aptos"/>
+              </a:rPr>
+              <a:t>Academia Dom Bosco</a:t>
+            </a:r>
+          </a:p>
+          <a:p>
+            <a:pPr algn="l"/>
+            <a:r>
+              <a:rPr sz="1300" b="0">
+                <a:solidFill>
+                  <a:srgbClr val="1A1A1A"/>
+                </a:solidFill>
+                <a:latin typeface="Aptos"/>
+              </a:rPr>
+              <a:t>Academia Runway</a:t>
+            </a:r>
+          </a:p>
+          <a:p>
+            <a:pPr algn="l"/>
+            <a:r>
+              <a:rPr sz="1300" b="0">
+                <a:solidFill>
+                  <a:srgbClr val="1A1A1A"/>
+                </a:solidFill>
+                <a:latin typeface="Aptos"/>
+              </a:rPr>
+              <a:t>Academia Team Nogueira</a:t>
+            </a:r>
+          </a:p>
+          <a:p>
+            <a:pPr algn="l"/>
+            <a:r>
+              <a:rPr sz="1300" b="0">
+                <a:solidFill>
+                  <a:srgbClr val="1A1A1A"/>
+                </a:solidFill>
+                <a:latin typeface="Aptos"/>
+              </a:rPr>
+              <a:t>Academia Vasco Neto</a:t>
+            </a:r>
+          </a:p>
+          <a:p>
+            <a:pPr algn="l"/>
+            <a:r>
+              <a:rPr sz="1300" b="0">
+                <a:solidFill>
+                  <a:srgbClr val="1A1A1A"/>
+                </a:solidFill>
+                <a:latin typeface="Aptos"/>
+              </a:rPr>
+              <a:t>ASBAC</a:t>
+            </a:r>
+          </a:p>
+          <a:p>
+            <a:pPr algn="l"/>
+            <a:r>
+              <a:rPr sz="1300" b="0">
+                <a:solidFill>
+                  <a:srgbClr val="1A1A1A"/>
+                </a:solidFill>
+                <a:latin typeface="Aptos"/>
+              </a:rPr>
+              <a:t>Associação Cristã de Moços</a:t>
+            </a:r>
+          </a:p>
+          <a:p>
+            <a:pPr algn="l"/>
+            <a:r>
+              <a:rPr sz="1300" b="0">
+                <a:solidFill>
+                  <a:srgbClr val="1A1A1A"/>
+                </a:solidFill>
+                <a:latin typeface="Aptos"/>
+              </a:rPr>
+              <a:t>ATP Atividades Físicas</a:t>
+            </a:r>
+          </a:p>
+          <a:p>
+            <a:pPr algn="l"/>
+            <a:r>
+              <a:rPr sz="1300" b="0">
+                <a:solidFill>
+                  <a:srgbClr val="1A1A1A"/>
+                </a:solidFill>
+                <a:latin typeface="Aptos"/>
+              </a:rPr>
+              <a:t>Bancorbrás Consórcios</a:t>
+            </a:r>
+          </a:p>
+          <a:p>
+            <a:pPr algn="l"/>
+            <a:r>
+              <a:rPr sz="1300" b="0">
+                <a:solidFill>
+                  <a:srgbClr val="1A1A1A"/>
+                </a:solidFill>
+                <a:latin typeface="Aptos"/>
+              </a:rPr>
+              <a:t>Bancorbrás Turismo</a:t>
+            </a:r>
+          </a:p>
+          <a:p>
+            <a:pPr algn="l"/>
+            <a:r>
+              <a:rPr sz="1300" b="0">
+                <a:solidFill>
+                  <a:srgbClr val="1A1A1A"/>
+                </a:solidFill>
+                <a:latin typeface="Aptos"/>
+              </a:rPr>
+              <a:t>Bay Park Resort Hotel</a:t>
+            </a:r>
+          </a:p>
+        </p:txBody>
+      </p:sp>
+      <p:sp>
+        <p:nvSpPr>
           <p:cNvPr id="8" name="Rounded Rectangle 7"/>
           <p:cNvSpPr/>
           <p:nvPr/>
         </p:nvSpPr>
         <p:spPr>
           <a:xfrm>
-            <a:off x="7635240" y="1737360"/>
-            <a:ext cx="3657600" cy="4206240"/>
+            <a:off x="6080760" y="2240280"/>
+            <a:ext cx="5303520" cy="3977639"/>
           </a:xfrm>
           <a:prstGeom prst="roundRect">
             <a:avLst/>
@@ -5842,339 +6900,207 @@
         </p:nvSpPr>
         <p:spPr>
           <a:xfrm>
-            <a:off x="4206240" y="2057400"/>
-            <a:ext cx="2834640" cy="3383280"/>
-          </a:xfrm>
-          <a:prstGeom prst="rect">
-            <a:avLst/>
-          </a:prstGeom>
-          <a:noFill/>
-        </p:spPr>
-        <p:txBody>
-          <a:bodyPr wrap="square" lIns="0" rIns="0" tIns="0" bIns="0">
-            <a:normAutofit/>
-          </a:bodyPr>
-          <a:lstStyle/>
-          <a:p>
-            <a:pPr algn="l"/>
-            <a:r>
-              <a:rPr sz="1400" b="0">
+            <a:off x="6281928" y="2441448"/>
+            <a:ext cx="4901184" cy="256032"/>
+          </a:xfrm>
+          <a:prstGeom prst="rect">
+            <a:avLst/>
+          </a:prstGeom>
+          <a:noFill/>
+        </p:spPr>
+        <p:txBody>
+          <a:bodyPr wrap="square" lIns="0" rIns="0" tIns="0" bIns="0">
+            <a:normAutofit/>
+          </a:bodyPr>
+          <a:lstStyle/>
+          <a:p>
+            <a:pPr algn="l"/>
+            <a:r>
+              <a:rPr sz="1600" b="1">
+                <a:solidFill>
+                  <a:srgbClr val="1E2761"/>
+                </a:solidFill>
+                <a:latin typeface="Aptos"/>
+              </a:rPr>
+              <a:t>Lazer e bem-estar 2</a:t>
+            </a:r>
+          </a:p>
+        </p:txBody>
+      </p:sp>
+      <p:sp>
+        <p:nvSpPr>
+          <p:cNvPr id="10" name="TextBox 9"/>
+          <p:cNvSpPr txBox="1"/>
+          <p:nvPr/>
+        </p:nvSpPr>
+        <p:spPr>
+          <a:xfrm>
+            <a:off x="6281928" y="2807208"/>
+            <a:ext cx="4901184" cy="3209543"/>
+          </a:xfrm>
+          <a:prstGeom prst="rect">
+            <a:avLst/>
+          </a:prstGeom>
+          <a:noFill/>
+        </p:spPr>
+        <p:txBody>
+          <a:bodyPr wrap="square" lIns="0" rIns="0" tIns="0" bIns="0">
+            <a:normAutofit/>
+          </a:bodyPr>
+          <a:lstStyle/>
+          <a:p>
+            <a:pPr algn="l"/>
+            <a:r>
+              <a:rPr sz="1300" b="0">
                 <a:solidFill>
                   <a:srgbClr val="1A1A1A"/>
                 </a:solidFill>
                 <a:latin typeface="Aptos"/>
               </a:rPr>
-              <a:t>Academia Club 22</a:t>
-            </a:r>
-          </a:p>
-          <a:p>
-            <a:pPr algn="l"/>
-            <a:r>
-              <a:rPr sz="1400" b="0">
+              <a:t>Camisaria Nyll</a:t>
+            </a:r>
+          </a:p>
+          <a:p>
+            <a:pPr algn="l"/>
+            <a:r>
+              <a:rPr sz="1300" b="0">
                 <a:solidFill>
                   <a:srgbClr val="1A1A1A"/>
                 </a:solidFill>
                 <a:latin typeface="Aptos"/>
               </a:rPr>
-              <a:t>Academia Companhia Athletica</a:t>
-            </a:r>
-          </a:p>
-          <a:p>
-            <a:pPr algn="l"/>
-            <a:r>
-              <a:rPr sz="1400" b="0">
+              <a:t>Clube dos Previdenciários</a:t>
+            </a:r>
+          </a:p>
+          <a:p>
+            <a:pPr algn="l"/>
+            <a:r>
+              <a:rPr sz="1300" b="0">
                 <a:solidFill>
                   <a:srgbClr val="1A1A1A"/>
                 </a:solidFill>
                 <a:latin typeface="Aptos"/>
               </a:rPr>
-              <a:t>Academia Dom Bosco</a:t>
-            </a:r>
-          </a:p>
-          <a:p>
-            <a:pPr algn="l"/>
-            <a:r>
-              <a:rPr sz="1400" b="0">
+              <a:t>Corpus Studio de Pilates</a:t>
+            </a:r>
+          </a:p>
+          <a:p>
+            <a:pPr algn="l"/>
+            <a:r>
+              <a:rPr sz="1300" b="0">
                 <a:solidFill>
                   <a:srgbClr val="1A1A1A"/>
                 </a:solidFill>
                 <a:latin typeface="Aptos"/>
               </a:rPr>
-              <a:t>Academia Runway</a:t>
-            </a:r>
-          </a:p>
-          <a:p>
-            <a:pPr algn="l"/>
-            <a:r>
-              <a:rPr sz="1400" b="0">
+              <a:t>Elia Spa</a:t>
+            </a:r>
+          </a:p>
+          <a:p>
+            <a:pPr algn="l"/>
+            <a:r>
+              <a:rPr sz="1300" b="0">
                 <a:solidFill>
                   <a:srgbClr val="1A1A1A"/>
                 </a:solidFill>
                 <a:latin typeface="Aptos"/>
               </a:rPr>
-              <a:t>Academia Team Nogueira</a:t>
-            </a:r>
-          </a:p>
-          <a:p>
-            <a:pPr algn="l"/>
-            <a:r>
-              <a:rPr sz="1400" b="0">
+              <a:t>Equilibriom Estética e Podologia</a:t>
+            </a:r>
+          </a:p>
+          <a:p>
+            <a:pPr algn="l"/>
+            <a:r>
+              <a:rPr sz="1300" b="0">
                 <a:solidFill>
                   <a:srgbClr val="1A1A1A"/>
                 </a:solidFill>
                 <a:latin typeface="Aptos"/>
               </a:rPr>
-              <a:t>Academia Vasco Neto</a:t>
-            </a:r>
-          </a:p>
-          <a:p>
-            <a:pPr algn="l"/>
-            <a:r>
-              <a:rPr sz="1400" b="0">
+              <a:t>Escola Ballet Garden</a:t>
+            </a:r>
+          </a:p>
+          <a:p>
+            <a:pPr algn="l"/>
+            <a:r>
+              <a:rPr sz="1300" b="0">
                 <a:solidFill>
                   <a:srgbClr val="1A1A1A"/>
                 </a:solidFill>
                 <a:latin typeface="Aptos"/>
               </a:rPr>
-              <a:t>ASBAC</a:t>
-            </a:r>
-          </a:p>
-          <a:p>
-            <a:pPr algn="l"/>
-            <a:r>
-              <a:rPr sz="1400" b="0">
+              <a:t>GrandBittar Hotel</a:t>
+            </a:r>
+          </a:p>
+          <a:p>
+            <a:pPr algn="l"/>
+            <a:r>
+              <a:rPr sz="1300" b="0">
                 <a:solidFill>
                   <a:srgbClr val="1A1A1A"/>
                 </a:solidFill>
                 <a:latin typeface="Aptos"/>
               </a:rPr>
-              <a:t>Associação Cristã de Moços</a:t>
-            </a:r>
-          </a:p>
-          <a:p>
-            <a:pPr algn="l"/>
-            <a:r>
-              <a:rPr sz="1400" b="0">
+              <a:t>Hotel Fazenda Mestre Darmas</a:t>
+            </a:r>
+          </a:p>
+          <a:p>
+            <a:pPr algn="l"/>
+            <a:r>
+              <a:rPr sz="1300" b="0">
                 <a:solidFill>
                   <a:srgbClr val="1A1A1A"/>
                 </a:solidFill>
                 <a:latin typeface="Aptos"/>
               </a:rPr>
-              <a:t>ATP Atividades Físicas</a:t>
-            </a:r>
-          </a:p>
-          <a:p>
-            <a:pPr algn="l"/>
-            <a:r>
-              <a:rPr sz="1400" b="0">
+              <a:t>Montreal Turismo</a:t>
+            </a:r>
+          </a:p>
+          <a:p>
+            <a:pPr algn="l"/>
+            <a:r>
+              <a:rPr sz="1300" b="0">
                 <a:solidFill>
                   <a:srgbClr val="1A1A1A"/>
                 </a:solidFill>
                 <a:latin typeface="Aptos"/>
               </a:rPr>
-              <a:t>Bancorbrás Consórcios</a:t>
-            </a:r>
-          </a:p>
-          <a:p>
-            <a:pPr algn="l"/>
-            <a:r>
-              <a:rPr sz="1400" b="0">
+              <a:t>Nuwa Spa</a:t>
+            </a:r>
+          </a:p>
+          <a:p>
+            <a:pPr algn="l"/>
+            <a:r>
+              <a:rPr sz="1300" b="0">
                 <a:solidFill>
                   <a:srgbClr val="1A1A1A"/>
                 </a:solidFill>
                 <a:latin typeface="Aptos"/>
               </a:rPr>
-              <a:t>Bancorbrás Turismo</a:t>
-            </a:r>
-          </a:p>
-          <a:p>
-            <a:pPr algn="l"/>
-            <a:r>
-              <a:rPr sz="1400" b="0">
+              <a:t>Studio Caracóis</a:t>
+            </a:r>
+          </a:p>
+          <a:p>
+            <a:pPr algn="l"/>
+            <a:r>
+              <a:rPr sz="1300" b="0">
                 <a:solidFill>
                   <a:srgbClr val="1A1A1A"/>
                 </a:solidFill>
                 <a:latin typeface="Aptos"/>
               </a:rPr>
-              <a:t>Bay Park Resort Hotel</a:t>
-            </a:r>
-          </a:p>
-        </p:txBody>
-      </p:sp>
-      <p:sp>
-        <p:nvSpPr>
-          <p:cNvPr id="10" name="TextBox 9"/>
-          <p:cNvSpPr txBox="1"/>
-          <p:nvPr/>
-        </p:nvSpPr>
-        <p:spPr>
-          <a:xfrm>
-            <a:off x="7863840" y="2057400"/>
-            <a:ext cx="2926080" cy="3383280"/>
-          </a:xfrm>
-          <a:prstGeom prst="rect">
-            <a:avLst/>
-          </a:prstGeom>
-          <a:noFill/>
-        </p:spPr>
-        <p:txBody>
-          <a:bodyPr wrap="square" lIns="0" rIns="0" tIns="0" bIns="0">
-            <a:normAutofit/>
-          </a:bodyPr>
-          <a:lstStyle/>
-          <a:p>
-            <a:pPr algn="l"/>
-            <a:r>
-              <a:rPr sz="1400" b="0">
+              <a:t>Studio Hair 180 Graus</a:t>
+            </a:r>
+          </a:p>
+          <a:p>
+            <a:pPr algn="l"/>
+            <a:r>
+              <a:rPr sz="1300" b="0">
                 <a:solidFill>
                   <a:srgbClr val="1A1A1A"/>
                 </a:solidFill>
                 <a:latin typeface="Aptos"/>
               </a:rPr>
-              <a:t>Camisaria Nyll</a:t>
-            </a:r>
-          </a:p>
-          <a:p>
-            <a:pPr algn="l"/>
-            <a:r>
-              <a:rPr sz="1400" b="0">
-                <a:solidFill>
-                  <a:srgbClr val="1A1A1A"/>
-                </a:solidFill>
-                <a:latin typeface="Aptos"/>
-              </a:rPr>
-              <a:t>Clube dos Previdenciários</a:t>
-            </a:r>
-          </a:p>
-          <a:p>
-            <a:pPr algn="l"/>
-            <a:r>
-              <a:rPr sz="1400" b="0">
-                <a:solidFill>
-                  <a:srgbClr val="1A1A1A"/>
-                </a:solidFill>
-                <a:latin typeface="Aptos"/>
-              </a:rPr>
-              <a:t>Corpus Studio de Pilates</a:t>
-            </a:r>
-          </a:p>
-          <a:p>
-            <a:pPr algn="l"/>
-            <a:r>
-              <a:rPr sz="1400" b="0">
-                <a:solidFill>
-                  <a:srgbClr val="1A1A1A"/>
-                </a:solidFill>
-                <a:latin typeface="Aptos"/>
-              </a:rPr>
-              <a:t>Elia Spa</a:t>
-            </a:r>
-          </a:p>
-          <a:p>
-            <a:pPr algn="l"/>
-            <a:r>
-              <a:rPr sz="1400" b="0">
-                <a:solidFill>
-                  <a:srgbClr val="1A1A1A"/>
-                </a:solidFill>
-                <a:latin typeface="Aptos"/>
-              </a:rPr>
-              <a:t>Equilibriom Estética e Podologia</a:t>
-            </a:r>
-          </a:p>
-          <a:p>
-            <a:pPr algn="l"/>
-            <a:r>
-              <a:rPr sz="1400" b="0">
-                <a:solidFill>
-                  <a:srgbClr val="1A1A1A"/>
-                </a:solidFill>
-                <a:latin typeface="Aptos"/>
-              </a:rPr>
-              <a:t>Escola Ballet Garden</a:t>
-            </a:r>
-          </a:p>
-          <a:p>
-            <a:pPr algn="l"/>
-            <a:r>
-              <a:rPr sz="1400" b="0">
-                <a:solidFill>
-                  <a:srgbClr val="1A1A1A"/>
-                </a:solidFill>
-                <a:latin typeface="Aptos"/>
-              </a:rPr>
-              <a:t>GrandBittar Hotel</a:t>
-            </a:r>
-          </a:p>
-          <a:p>
-            <a:pPr algn="l"/>
-            <a:r>
-              <a:rPr sz="1400" b="0">
-                <a:solidFill>
-                  <a:srgbClr val="1A1A1A"/>
-                </a:solidFill>
-                <a:latin typeface="Aptos"/>
-              </a:rPr>
-              <a:t>Hotel Fazenda Mestre Darmas</a:t>
-            </a:r>
-          </a:p>
-          <a:p>
-            <a:pPr algn="l"/>
-            <a:r>
-              <a:rPr sz="1400" b="0">
-                <a:solidFill>
-                  <a:srgbClr val="1A1A1A"/>
-                </a:solidFill>
-                <a:latin typeface="Aptos"/>
-              </a:rPr>
-              <a:t>Montreal Turismo</a:t>
-            </a:r>
-          </a:p>
-          <a:p>
-            <a:pPr algn="l"/>
-            <a:r>
-              <a:rPr sz="1400" b="0">
-                <a:solidFill>
-                  <a:srgbClr val="1A1A1A"/>
-                </a:solidFill>
-                <a:latin typeface="Aptos"/>
-              </a:rPr>
-              <a:t>Nuwa Spa</a:t>
-            </a:r>
-          </a:p>
-          <a:p>
-            <a:pPr algn="l"/>
-            <a:r>
-              <a:rPr sz="1400" b="0">
-                <a:solidFill>
-                  <a:srgbClr val="1A1A1A"/>
-                </a:solidFill>
-                <a:latin typeface="Aptos"/>
-              </a:rPr>
-              <a:t>Studio Caracóis</a:t>
-            </a:r>
-          </a:p>
-          <a:p>
-            <a:pPr algn="l"/>
-            <a:r>
-              <a:rPr sz="1400" b="0">
-                <a:solidFill>
-                  <a:srgbClr val="1A1A1A"/>
-                </a:solidFill>
-                <a:latin typeface="Aptos"/>
-              </a:rPr>
-              <a:t>Studio Hair 180 Graus</a:t>
-            </a:r>
-          </a:p>
-          <a:p>
-            <a:pPr algn="l"/>
-            <a:r>
-              <a:rPr sz="1400" b="0">
-                <a:solidFill>
-                  <a:srgbClr val="1A1A1A"/>
-                </a:solidFill>
-                <a:latin typeface="Aptos"/>
-              </a:rPr>
               <a:t>Thermas do Rio Quente</a:t>
             </a:r>
           </a:p>
@@ -6188,8 +7114,8 @@
         </p:nvSpPr>
         <p:spPr>
           <a:xfrm>
-            <a:off x="10881360" y="6400800"/>
-            <a:ext cx="640080" cy="228600"/>
+            <a:off x="10808208" y="6144768"/>
+            <a:ext cx="713232" cy="228600"/>
           </a:xfrm>
           <a:prstGeom prst="rect">
             <a:avLst/>
@@ -6210,7 +7136,7 @@
                 </a:solidFill>
                 <a:latin typeface="Aptos"/>
               </a:rPr>
-              <a:t>13 / 14</a:t>
+              <a:t>15 / 16</a:t>
             </a:r>
           </a:p>
         </p:txBody>
@@ -6223,7 +7149,7 @@
 </p:sld>
 </file>
 
-<file path=ppt/slides/slide14.xml><?xml version="1.0" encoding="utf-8"?>
+<file path=ppt/slides/slide16.xml><?xml version="1.0" encoding="utf-8"?>
 <p:sld xmlns:a="http://schemas.openxmlformats.org/drawingml/2006/main" xmlns:p="http://schemas.openxmlformats.org/presentationml/2006/main" xmlns:r="http://schemas.openxmlformats.org/officeDocument/2006/relationships">
   <p:cSld>
     <p:bg>
@@ -6813,8 +7739,8 @@
         </p:nvSpPr>
         <p:spPr>
           <a:xfrm>
-            <a:off x="10881360" y="6400800"/>
-            <a:ext cx="640080" cy="228600"/>
+            <a:off x="10808208" y="6144768"/>
+            <a:ext cx="713232" cy="228600"/>
           </a:xfrm>
           <a:prstGeom prst="rect">
             <a:avLst/>
@@ -6835,7 +7761,7 @@
                 </a:solidFill>
                 <a:latin typeface="Aptos"/>
               </a:rPr>
-              <a:t>14 / 14</a:t>
+              <a:t>16 / 16</a:t>
             </a:r>
           </a:p>
         </p:txBody>
@@ -7589,8 +8515,8 @@
         </p:nvSpPr>
         <p:spPr>
           <a:xfrm>
-            <a:off x="10881360" y="6400800"/>
-            <a:ext cx="640080" cy="228600"/>
+            <a:off x="10808208" y="6144768"/>
+            <a:ext cx="713232" cy="228600"/>
           </a:xfrm>
           <a:prstGeom prst="rect">
             <a:avLst/>
@@ -7611,7 +8537,7 @@
                 </a:solidFill>
                 <a:latin typeface="Aptos"/>
               </a:rPr>
-              <a:t>02 / 14</a:t>
+              <a:t>02 / 16</a:t>
             </a:r>
           </a:p>
         </p:txBody>
@@ -8055,8 +8981,8 @@
         </p:nvSpPr>
         <p:spPr>
           <a:xfrm>
-            <a:off x="10881360" y="6400800"/>
-            <a:ext cx="640080" cy="228600"/>
+            <a:off x="10808208" y="6144768"/>
+            <a:ext cx="713232" cy="228600"/>
           </a:xfrm>
           <a:prstGeom prst="rect">
             <a:avLst/>
@@ -8077,7 +9003,7 @@
                 </a:solidFill>
                 <a:latin typeface="Aptos"/>
               </a:rPr>
-              <a:t>03 / 14</a:t>
+              <a:t>03 / 16</a:t>
             </a:r>
           </a:p>
         </p:txBody>
@@ -8541,8 +9467,8 @@
         </p:nvSpPr>
         <p:spPr>
           <a:xfrm>
-            <a:off x="10881360" y="6400800"/>
-            <a:ext cx="640080" cy="228600"/>
+            <a:off x="10808208" y="6144768"/>
+            <a:ext cx="713232" cy="228600"/>
           </a:xfrm>
           <a:prstGeom prst="rect">
             <a:avLst/>
@@ -8563,7 +9489,7 @@
                 </a:solidFill>
                 <a:latin typeface="Aptos"/>
               </a:rPr>
-              <a:t>04 / 14</a:t>
+              <a:t>04 / 16</a:t>
             </a:r>
           </a:p>
         </p:txBody>
@@ -9627,8 +10553,8 @@
         </p:nvSpPr>
         <p:spPr>
           <a:xfrm>
-            <a:off x="10881360" y="6400800"/>
-            <a:ext cx="640080" cy="228600"/>
+            <a:off x="10808208" y="6144768"/>
+            <a:ext cx="713232" cy="228600"/>
           </a:xfrm>
           <a:prstGeom prst="rect">
             <a:avLst/>
@@ -9649,7 +10575,7 @@
                 </a:solidFill>
                 <a:latin typeface="Aptos"/>
               </a:rPr>
-              <a:t>05 / 14</a:t>
+              <a:t>05 / 16</a:t>
             </a:r>
           </a:p>
         </p:txBody>
@@ -10368,8 +11294,8 @@
         </p:nvSpPr>
         <p:spPr>
           <a:xfrm>
-            <a:off x="10881360" y="6400800"/>
-            <a:ext cx="640080" cy="228600"/>
+            <a:off x="10808208" y="6144768"/>
+            <a:ext cx="713232" cy="228600"/>
           </a:xfrm>
           <a:prstGeom prst="rect">
             <a:avLst/>
@@ -10390,7 +11316,7 @@
                 </a:solidFill>
                 <a:latin typeface="Aptos"/>
               </a:rPr>
-              <a:t>06 / 14</a:t>
+              <a:t>06 / 16</a:t>
             </a:r>
           </a:p>
         </p:txBody>
@@ -10938,8 +11864,8 @@
         </p:nvSpPr>
         <p:spPr>
           <a:xfrm>
-            <a:off x="10881360" y="6400800"/>
-            <a:ext cx="640080" cy="228600"/>
+            <a:off x="10808208" y="6144768"/>
+            <a:ext cx="713232" cy="228600"/>
           </a:xfrm>
           <a:prstGeom prst="rect">
             <a:avLst/>
@@ -10960,7 +11886,7 @@
                 </a:solidFill>
                 <a:latin typeface="Aptos"/>
               </a:rPr>
-              <a:t>07 / 14</a:t>
+              <a:t>07 / 16</a:t>
             </a:r>
           </a:p>
         </p:txBody>
@@ -11840,8 +12766,8 @@
         </p:nvSpPr>
         <p:spPr>
           <a:xfrm>
-            <a:off x="10881360" y="6400800"/>
-            <a:ext cx="640080" cy="228600"/>
+            <a:off x="10808208" y="6144768"/>
+            <a:ext cx="713232" cy="228600"/>
           </a:xfrm>
           <a:prstGeom prst="rect">
             <a:avLst/>
@@ -11862,7 +12788,7 @@
                 </a:solidFill>
                 <a:latin typeface="Aptos"/>
               </a:rPr>
-              <a:t>08 / 14</a:t>
+              <a:t>08 / 16</a:t>
             </a:r>
           </a:p>
         </p:txBody>
@@ -12422,8 +13348,8 @@
         </p:nvSpPr>
         <p:spPr>
           <a:xfrm>
-            <a:off x="10881360" y="6400800"/>
-            <a:ext cx="640080" cy="228600"/>
+            <a:off x="10808208" y="6144768"/>
+            <a:ext cx="713232" cy="228600"/>
           </a:xfrm>
           <a:prstGeom prst="rect">
             <a:avLst/>
@@ -12444,7 +13370,7 @@
                 </a:solidFill>
                 <a:latin typeface="Aptos"/>
               </a:rPr>
-              <a:t>09 / 14</a:t>
+              <a:t>09 / 16</a:t>
             </a:r>
           </a:p>
         </p:txBody>

</xml_diff>